<commit_message>
Add dark and light mode icons for UI toolbar
- Created modedark.svg for dark mode representation.
- Created modelight.svg for light mode representation.
</commit_message>
<xml_diff>
--- a/Icons_UI/bcpst.pptx
+++ b/Icons_UI/bcpst.pptx
@@ -5,8 +5,9 @@
     <p:sldMasterId id="2147483648" r:id="rId1"/>
   </p:sldMasterIdLst>
   <p:sldIdLst>
-    <p:sldId id="257" r:id="rId2"/>
-    <p:sldId id="256" r:id="rId3"/>
+    <p:sldId id="258" r:id="rId2"/>
+    <p:sldId id="257" r:id="rId3"/>
+    <p:sldId id="256" r:id="rId4"/>
   </p:sldIdLst>
   <p:sldSz cx="12192000" cy="6858000"/>
   <p:notesSz cx="6858000" cy="9144000"/>
@@ -838,6 +839,636 @@
 <file path=ppt/slides/slide1.xml><?xml version="1.0" encoding="utf-8"?>
 <p:sld xmlns:a="http://schemas.openxmlformats.org/drawingml/2006/main" xmlns:r="http://schemas.openxmlformats.org/officeDocument/2006/relationships" xmlns:p="http://schemas.openxmlformats.org/presentationml/2006/main">
   <p:cSld>
+    <p:spTree>
+      <p:nvGrpSpPr>
+        <p:cNvPr id="1" name=""/>
+        <p:cNvGrpSpPr/>
+        <p:nvPr/>
+      </p:nvGrpSpPr>
+      <p:grpSpPr>
+        <a:xfrm>
+          <a:off x="0" y="0"/>
+          <a:ext cx="0" cy="0"/>
+          <a:chOff x="0" y="0"/>
+          <a:chExt cx="0" cy="0"/>
+        </a:xfrm>
+      </p:grpSpPr>
+      <p:pic>
+        <p:nvPicPr>
+          <p:cNvPr id="7" name="Graphic 6">
+            <a:extLst>
+              <a:ext uri="{FF2B5EF4-FFF2-40B4-BE49-F238E27FC236}">
+                <a16:creationId xmlns:a16="http://schemas.microsoft.com/office/drawing/2014/main" id="{E5EAD930-756B-D9F1-C4F3-6B4C9C051D26}"/>
+              </a:ext>
+            </a:extLst>
+          </p:cNvPr>
+          <p:cNvPicPr>
+            <a:picLocks noChangeAspect="1"/>
+          </p:cNvPicPr>
+          <p:nvPr/>
+        </p:nvPicPr>
+        <p:blipFill>
+          <a:blip r:embed="rId2">
+            <a:extLst>
+              <a:ext uri="{96DAC541-7B7A-43D3-8B79-37D633B846F1}">
+                <asvg:svgBlip xmlns:asvg="http://schemas.microsoft.com/office/drawing/2016/SVG/main" r:embed="rId3"/>
+              </a:ext>
+            </a:extLst>
+          </a:blip>
+          <a:stretch>
+            <a:fillRect/>
+          </a:stretch>
+        </p:blipFill>
+        <p:spPr>
+          <a:xfrm>
+            <a:off x="912827" y="746156"/>
+            <a:ext cx="1440000" cy="1040462"/>
+          </a:xfrm>
+          <a:prstGeom prst="rect">
+            <a:avLst/>
+          </a:prstGeom>
+        </p:spPr>
+      </p:pic>
+      <p:pic>
+        <p:nvPicPr>
+          <p:cNvPr id="9" name="Graphic 8">
+            <a:extLst>
+              <a:ext uri="{FF2B5EF4-FFF2-40B4-BE49-F238E27FC236}">
+                <a16:creationId xmlns:a16="http://schemas.microsoft.com/office/drawing/2014/main" id="{2DFC2D59-AF15-FFE3-B5EB-D19F3410AA20}"/>
+              </a:ext>
+            </a:extLst>
+          </p:cNvPr>
+          <p:cNvPicPr>
+            <a:picLocks noChangeAspect="1"/>
+          </p:cNvPicPr>
+          <p:nvPr/>
+        </p:nvPicPr>
+        <p:blipFill>
+          <a:blip r:embed="rId4">
+            <a:extLst>
+              <a:ext uri="{96DAC541-7B7A-43D3-8B79-37D633B846F1}">
+                <asvg:svgBlip xmlns:asvg="http://schemas.microsoft.com/office/drawing/2016/SVG/main" r:embed="rId5"/>
+              </a:ext>
+            </a:extLst>
+          </a:blip>
+          <a:stretch>
+            <a:fillRect/>
+          </a:stretch>
+        </p:blipFill>
+        <p:spPr>
+          <a:xfrm>
+            <a:off x="3162461" y="546387"/>
+            <a:ext cx="1358961" cy="1440000"/>
+          </a:xfrm>
+          <a:prstGeom prst="rect">
+            <a:avLst/>
+          </a:prstGeom>
+        </p:spPr>
+      </p:pic>
+      <p:pic>
+        <p:nvPicPr>
+          <p:cNvPr id="11" name="Graphic 10">
+            <a:extLst>
+              <a:ext uri="{FF2B5EF4-FFF2-40B4-BE49-F238E27FC236}">
+                <a16:creationId xmlns:a16="http://schemas.microsoft.com/office/drawing/2014/main" id="{82FFAE92-C5DA-96C4-03CA-25E48AA00A49}"/>
+              </a:ext>
+            </a:extLst>
+          </p:cNvPr>
+          <p:cNvPicPr>
+            <a:picLocks noChangeAspect="1"/>
+          </p:cNvPicPr>
+          <p:nvPr/>
+        </p:nvPicPr>
+        <p:blipFill>
+          <a:blip r:embed="rId6">
+            <a:extLst>
+              <a:ext uri="{96DAC541-7B7A-43D3-8B79-37D633B846F1}">
+                <asvg:svgBlip xmlns:asvg="http://schemas.microsoft.com/office/drawing/2016/SVG/main" r:embed="rId7"/>
+              </a:ext>
+            </a:extLst>
+          </a:blip>
+          <a:stretch>
+            <a:fillRect/>
+          </a:stretch>
+        </p:blipFill>
+        <p:spPr>
+          <a:xfrm>
+            <a:off x="5331056" y="550818"/>
+            <a:ext cx="1440000" cy="1431139"/>
+          </a:xfrm>
+          <a:prstGeom prst="rect">
+            <a:avLst/>
+          </a:prstGeom>
+        </p:spPr>
+      </p:pic>
+      <p:pic>
+        <p:nvPicPr>
+          <p:cNvPr id="13" name="Graphic 12">
+            <a:extLst>
+              <a:ext uri="{FF2B5EF4-FFF2-40B4-BE49-F238E27FC236}">
+                <a16:creationId xmlns:a16="http://schemas.microsoft.com/office/drawing/2014/main" id="{73E2A251-19FD-61F0-7453-5E34FE6644E5}"/>
+              </a:ext>
+            </a:extLst>
+          </p:cNvPr>
+          <p:cNvPicPr>
+            <a:picLocks noChangeAspect="1"/>
+          </p:cNvPicPr>
+          <p:nvPr/>
+        </p:nvPicPr>
+        <p:blipFill>
+          <a:blip r:embed="rId8">
+            <a:extLst>
+              <a:ext uri="{96DAC541-7B7A-43D3-8B79-37D633B846F1}">
+                <asvg:svgBlip xmlns:asvg="http://schemas.microsoft.com/office/drawing/2016/SVG/main" r:embed="rId9"/>
+              </a:ext>
+            </a:extLst>
+          </a:blip>
+          <a:stretch>
+            <a:fillRect/>
+          </a:stretch>
+        </p:blipFill>
+        <p:spPr>
+          <a:xfrm>
+            <a:off x="7580690" y="546387"/>
+            <a:ext cx="1440000" cy="1440000"/>
+          </a:xfrm>
+          <a:prstGeom prst="rect">
+            <a:avLst/>
+          </a:prstGeom>
+        </p:spPr>
+      </p:pic>
+      <p:pic>
+        <p:nvPicPr>
+          <p:cNvPr id="15" name="Graphic 14">
+            <a:extLst>
+              <a:ext uri="{FF2B5EF4-FFF2-40B4-BE49-F238E27FC236}">
+                <a16:creationId xmlns:a16="http://schemas.microsoft.com/office/drawing/2014/main" id="{6CC2A570-2385-2863-FE03-5BD02101E8EB}"/>
+              </a:ext>
+            </a:extLst>
+          </p:cNvPr>
+          <p:cNvPicPr>
+            <a:picLocks noChangeAspect="1"/>
+          </p:cNvPicPr>
+          <p:nvPr/>
+        </p:nvPicPr>
+        <p:blipFill>
+          <a:blip r:embed="rId10">
+            <a:extLst>
+              <a:ext uri="{96DAC541-7B7A-43D3-8B79-37D633B846F1}">
+                <asvg:svgBlip xmlns:asvg="http://schemas.microsoft.com/office/drawing/2016/SVG/main" r:embed="rId11"/>
+              </a:ext>
+            </a:extLst>
+          </a:blip>
+          <a:stretch>
+            <a:fillRect/>
+          </a:stretch>
+        </p:blipFill>
+        <p:spPr>
+          <a:xfrm>
+            <a:off x="9830323" y="546387"/>
+            <a:ext cx="1358960" cy="1440000"/>
+          </a:xfrm>
+          <a:prstGeom prst="rect">
+            <a:avLst/>
+          </a:prstGeom>
+        </p:spPr>
+      </p:pic>
+      <p:pic>
+        <p:nvPicPr>
+          <p:cNvPr id="75" name="Graphic 74">
+            <a:extLst>
+              <a:ext uri="{FF2B5EF4-FFF2-40B4-BE49-F238E27FC236}">
+                <a16:creationId xmlns:a16="http://schemas.microsoft.com/office/drawing/2014/main" id="{337DFBAF-91A8-CC5E-1CB7-682F863891E2}"/>
+              </a:ext>
+            </a:extLst>
+          </p:cNvPr>
+          <p:cNvPicPr>
+            <a:picLocks noChangeAspect="1"/>
+          </p:cNvPicPr>
+          <p:nvPr/>
+        </p:nvPicPr>
+        <p:blipFill>
+          <a:blip r:embed="rId2">
+            <a:alphaModFix/>
+            <a:extLst>
+              <a:ext uri="{96DAC541-7B7A-43D3-8B79-37D633B846F1}">
+                <asvg:svgBlip xmlns:asvg="http://schemas.microsoft.com/office/drawing/2016/SVG/main" r:embed="rId12"/>
+              </a:ext>
+            </a:extLst>
+          </a:blip>
+          <a:stretch>
+            <a:fillRect/>
+          </a:stretch>
+        </p:blipFill>
+        <p:spPr>
+          <a:xfrm>
+            <a:off x="911196" y="2908768"/>
+            <a:ext cx="1440000" cy="1040462"/>
+          </a:xfrm>
+          <a:prstGeom prst="rect">
+            <a:avLst/>
+          </a:prstGeom>
+          <a:effectLst>
+            <a:glow rad="368300">
+              <a:schemeClr val="bg1"/>
+            </a:glow>
+          </a:effectLst>
+        </p:spPr>
+      </p:pic>
+      <p:pic>
+        <p:nvPicPr>
+          <p:cNvPr id="76" name="Graphic 75">
+            <a:extLst>
+              <a:ext uri="{FF2B5EF4-FFF2-40B4-BE49-F238E27FC236}">
+                <a16:creationId xmlns:a16="http://schemas.microsoft.com/office/drawing/2014/main" id="{5BB39FE4-D280-618E-E641-347D42987130}"/>
+              </a:ext>
+            </a:extLst>
+          </p:cNvPr>
+          <p:cNvPicPr>
+            <a:picLocks noChangeAspect="1"/>
+          </p:cNvPicPr>
+          <p:nvPr/>
+        </p:nvPicPr>
+        <p:blipFill>
+          <a:blip r:embed="rId4">
+            <a:alphaModFix/>
+            <a:extLst>
+              <a:ext uri="{96DAC541-7B7A-43D3-8B79-37D633B846F1}">
+                <asvg:svgBlip xmlns:asvg="http://schemas.microsoft.com/office/drawing/2016/SVG/main" r:embed="rId13"/>
+              </a:ext>
+            </a:extLst>
+          </a:blip>
+          <a:stretch>
+            <a:fillRect/>
+          </a:stretch>
+        </p:blipFill>
+        <p:spPr>
+          <a:xfrm>
+            <a:off x="3149811" y="2708999"/>
+            <a:ext cx="1358961" cy="1440000"/>
+          </a:xfrm>
+          <a:prstGeom prst="rect">
+            <a:avLst/>
+          </a:prstGeom>
+          <a:effectLst>
+            <a:glow rad="368300">
+              <a:schemeClr val="bg1"/>
+            </a:glow>
+          </a:effectLst>
+        </p:spPr>
+      </p:pic>
+      <p:pic>
+        <p:nvPicPr>
+          <p:cNvPr id="77" name="Graphic 76">
+            <a:extLst>
+              <a:ext uri="{FF2B5EF4-FFF2-40B4-BE49-F238E27FC236}">
+                <a16:creationId xmlns:a16="http://schemas.microsoft.com/office/drawing/2014/main" id="{0648C269-76BD-0BEC-7F0B-96B390B95BA0}"/>
+              </a:ext>
+            </a:extLst>
+          </p:cNvPr>
+          <p:cNvPicPr>
+            <a:picLocks noChangeAspect="1"/>
+          </p:cNvPicPr>
+          <p:nvPr/>
+        </p:nvPicPr>
+        <p:blipFill>
+          <a:blip r:embed="rId6">
+            <a:alphaModFix/>
+            <a:extLst>
+              <a:ext uri="{96DAC541-7B7A-43D3-8B79-37D633B846F1}">
+                <asvg:svgBlip xmlns:asvg="http://schemas.microsoft.com/office/drawing/2016/SVG/main" r:embed="rId14"/>
+              </a:ext>
+            </a:extLst>
+          </a:blip>
+          <a:stretch>
+            <a:fillRect/>
+          </a:stretch>
+        </p:blipFill>
+        <p:spPr>
+          <a:xfrm>
+            <a:off x="5331056" y="2713430"/>
+            <a:ext cx="1440000" cy="1431139"/>
+          </a:xfrm>
+          <a:prstGeom prst="rect">
+            <a:avLst/>
+          </a:prstGeom>
+          <a:effectLst>
+            <a:glow rad="368300">
+              <a:schemeClr val="bg1"/>
+            </a:glow>
+          </a:effectLst>
+        </p:spPr>
+      </p:pic>
+      <p:pic>
+        <p:nvPicPr>
+          <p:cNvPr id="78" name="Graphic 77">
+            <a:extLst>
+              <a:ext uri="{FF2B5EF4-FFF2-40B4-BE49-F238E27FC236}">
+                <a16:creationId xmlns:a16="http://schemas.microsoft.com/office/drawing/2014/main" id="{C3E6FA7E-1389-7514-8A5E-AF2511A4A4F0}"/>
+              </a:ext>
+            </a:extLst>
+          </p:cNvPr>
+          <p:cNvPicPr>
+            <a:picLocks noChangeAspect="1"/>
+          </p:cNvPicPr>
+          <p:nvPr/>
+        </p:nvPicPr>
+        <p:blipFill>
+          <a:blip r:embed="rId8">
+            <a:alphaModFix/>
+            <a:extLst>
+              <a:ext uri="{96DAC541-7B7A-43D3-8B79-37D633B846F1}">
+                <asvg:svgBlip xmlns:asvg="http://schemas.microsoft.com/office/drawing/2016/SVG/main" r:embed="rId15"/>
+              </a:ext>
+            </a:extLst>
+          </a:blip>
+          <a:stretch>
+            <a:fillRect/>
+          </a:stretch>
+        </p:blipFill>
+        <p:spPr>
+          <a:xfrm>
+            <a:off x="7576444" y="2708999"/>
+            <a:ext cx="1440000" cy="1440000"/>
+          </a:xfrm>
+          <a:prstGeom prst="rect">
+            <a:avLst/>
+          </a:prstGeom>
+          <a:effectLst>
+            <a:glow rad="368300">
+              <a:schemeClr val="bg1"/>
+            </a:glow>
+          </a:effectLst>
+        </p:spPr>
+      </p:pic>
+      <p:pic>
+        <p:nvPicPr>
+          <p:cNvPr id="79" name="Graphic 78">
+            <a:extLst>
+              <a:ext uri="{FF2B5EF4-FFF2-40B4-BE49-F238E27FC236}">
+                <a16:creationId xmlns:a16="http://schemas.microsoft.com/office/drawing/2014/main" id="{441A969D-6069-F418-6C9B-1F7C243CCBBE}"/>
+              </a:ext>
+            </a:extLst>
+          </p:cNvPr>
+          <p:cNvPicPr>
+            <a:picLocks noChangeAspect="1"/>
+          </p:cNvPicPr>
+          <p:nvPr/>
+        </p:nvPicPr>
+        <p:blipFill>
+          <a:blip r:embed="rId10">
+            <a:alphaModFix/>
+            <a:extLst>
+              <a:ext uri="{96DAC541-7B7A-43D3-8B79-37D633B846F1}">
+                <asvg:svgBlip xmlns:asvg="http://schemas.microsoft.com/office/drawing/2016/SVG/main" r:embed="rId16"/>
+              </a:ext>
+            </a:extLst>
+          </a:blip>
+          <a:stretch>
+            <a:fillRect/>
+          </a:stretch>
+        </p:blipFill>
+        <p:spPr>
+          <a:xfrm>
+            <a:off x="9815059" y="2708999"/>
+            <a:ext cx="1358960" cy="1440000"/>
+          </a:xfrm>
+          <a:prstGeom prst="rect">
+            <a:avLst/>
+          </a:prstGeom>
+          <a:effectLst>
+            <a:glow rad="368300">
+              <a:schemeClr val="bg1"/>
+            </a:glow>
+          </a:effectLst>
+        </p:spPr>
+      </p:pic>
+      <p:pic>
+        <p:nvPicPr>
+          <p:cNvPr id="80" name="Graphic 79">
+            <a:extLst>
+              <a:ext uri="{FF2B5EF4-FFF2-40B4-BE49-F238E27FC236}">
+                <a16:creationId xmlns:a16="http://schemas.microsoft.com/office/drawing/2014/main" id="{B0FCB388-9DB9-3E5F-309F-A8B1726FF667}"/>
+              </a:ext>
+            </a:extLst>
+          </p:cNvPr>
+          <p:cNvPicPr>
+            <a:picLocks noChangeAspect="1"/>
+          </p:cNvPicPr>
+          <p:nvPr/>
+        </p:nvPicPr>
+        <p:blipFill>
+          <a:blip r:embed="rId2">
+            <a:alphaModFix/>
+            <a:extLst>
+              <a:ext uri="{96DAC541-7B7A-43D3-8B79-37D633B846F1}">
+                <asvg:svgBlip xmlns:asvg="http://schemas.microsoft.com/office/drawing/2016/SVG/main" r:embed="rId12"/>
+              </a:ext>
+            </a:extLst>
+          </a:blip>
+          <a:stretch>
+            <a:fillRect/>
+          </a:stretch>
+        </p:blipFill>
+        <p:spPr>
+          <a:xfrm>
+            <a:off x="911196" y="5071380"/>
+            <a:ext cx="1440000" cy="1040462"/>
+          </a:xfrm>
+          <a:prstGeom prst="rect">
+            <a:avLst/>
+          </a:prstGeom>
+          <a:effectLst>
+            <a:glow rad="368300">
+              <a:schemeClr val="tx1"/>
+            </a:glow>
+          </a:effectLst>
+        </p:spPr>
+      </p:pic>
+      <p:pic>
+        <p:nvPicPr>
+          <p:cNvPr id="81" name="Graphic 80">
+            <a:extLst>
+              <a:ext uri="{FF2B5EF4-FFF2-40B4-BE49-F238E27FC236}">
+                <a16:creationId xmlns:a16="http://schemas.microsoft.com/office/drawing/2014/main" id="{4F5ACCE8-29E9-DC36-2920-EB14B38741C1}"/>
+              </a:ext>
+            </a:extLst>
+          </p:cNvPr>
+          <p:cNvPicPr>
+            <a:picLocks noChangeAspect="1"/>
+          </p:cNvPicPr>
+          <p:nvPr/>
+        </p:nvPicPr>
+        <p:blipFill>
+          <a:blip r:embed="rId4">
+            <a:alphaModFix/>
+            <a:extLst>
+              <a:ext uri="{96DAC541-7B7A-43D3-8B79-37D633B846F1}">
+                <asvg:svgBlip xmlns:asvg="http://schemas.microsoft.com/office/drawing/2016/SVG/main" r:embed="rId13"/>
+              </a:ext>
+            </a:extLst>
+          </a:blip>
+          <a:stretch>
+            <a:fillRect/>
+          </a:stretch>
+        </p:blipFill>
+        <p:spPr>
+          <a:xfrm>
+            <a:off x="3149811" y="4871611"/>
+            <a:ext cx="1358961" cy="1440000"/>
+          </a:xfrm>
+          <a:prstGeom prst="rect">
+            <a:avLst/>
+          </a:prstGeom>
+          <a:effectLst>
+            <a:glow rad="368300">
+              <a:schemeClr val="tx1"/>
+            </a:glow>
+          </a:effectLst>
+        </p:spPr>
+      </p:pic>
+      <p:pic>
+        <p:nvPicPr>
+          <p:cNvPr id="82" name="Graphic 81">
+            <a:extLst>
+              <a:ext uri="{FF2B5EF4-FFF2-40B4-BE49-F238E27FC236}">
+                <a16:creationId xmlns:a16="http://schemas.microsoft.com/office/drawing/2014/main" id="{3A2CF5A8-D4A6-C5A8-AA0B-11BB6B2F0FBA}"/>
+              </a:ext>
+            </a:extLst>
+          </p:cNvPr>
+          <p:cNvPicPr>
+            <a:picLocks noChangeAspect="1"/>
+          </p:cNvPicPr>
+          <p:nvPr/>
+        </p:nvPicPr>
+        <p:blipFill>
+          <a:blip r:embed="rId6">
+            <a:alphaModFix/>
+            <a:extLst>
+              <a:ext uri="{96DAC541-7B7A-43D3-8B79-37D633B846F1}">
+                <asvg:svgBlip xmlns:asvg="http://schemas.microsoft.com/office/drawing/2016/SVG/main" r:embed="rId14"/>
+              </a:ext>
+            </a:extLst>
+          </a:blip>
+          <a:stretch>
+            <a:fillRect/>
+          </a:stretch>
+        </p:blipFill>
+        <p:spPr>
+          <a:xfrm>
+            <a:off x="5331056" y="4876042"/>
+            <a:ext cx="1440000" cy="1431139"/>
+          </a:xfrm>
+          <a:prstGeom prst="rect">
+            <a:avLst/>
+          </a:prstGeom>
+          <a:effectLst>
+            <a:glow rad="368300">
+              <a:schemeClr val="tx1"/>
+            </a:glow>
+          </a:effectLst>
+        </p:spPr>
+      </p:pic>
+      <p:pic>
+        <p:nvPicPr>
+          <p:cNvPr id="83" name="Graphic 82">
+            <a:extLst>
+              <a:ext uri="{FF2B5EF4-FFF2-40B4-BE49-F238E27FC236}">
+                <a16:creationId xmlns:a16="http://schemas.microsoft.com/office/drawing/2014/main" id="{2A933643-4786-C5B5-77B4-0EEABD319215}"/>
+              </a:ext>
+            </a:extLst>
+          </p:cNvPr>
+          <p:cNvPicPr>
+            <a:picLocks noChangeAspect="1"/>
+          </p:cNvPicPr>
+          <p:nvPr/>
+        </p:nvPicPr>
+        <p:blipFill>
+          <a:blip r:embed="rId8">
+            <a:alphaModFix/>
+            <a:extLst>
+              <a:ext uri="{96DAC541-7B7A-43D3-8B79-37D633B846F1}">
+                <asvg:svgBlip xmlns:asvg="http://schemas.microsoft.com/office/drawing/2016/SVG/main" r:embed="rId15"/>
+              </a:ext>
+            </a:extLst>
+          </a:blip>
+          <a:stretch>
+            <a:fillRect/>
+          </a:stretch>
+        </p:blipFill>
+        <p:spPr>
+          <a:xfrm>
+            <a:off x="7576444" y="4871611"/>
+            <a:ext cx="1440000" cy="1440000"/>
+          </a:xfrm>
+          <a:prstGeom prst="rect">
+            <a:avLst/>
+          </a:prstGeom>
+          <a:effectLst>
+            <a:glow rad="368300">
+              <a:schemeClr val="tx1"/>
+            </a:glow>
+          </a:effectLst>
+        </p:spPr>
+      </p:pic>
+      <p:pic>
+        <p:nvPicPr>
+          <p:cNvPr id="84" name="Graphic 83">
+            <a:extLst>
+              <a:ext uri="{FF2B5EF4-FFF2-40B4-BE49-F238E27FC236}">
+                <a16:creationId xmlns:a16="http://schemas.microsoft.com/office/drawing/2014/main" id="{E0861FB2-0FBE-944F-7B7C-7D913AEAF0BC}"/>
+              </a:ext>
+            </a:extLst>
+          </p:cNvPr>
+          <p:cNvPicPr>
+            <a:picLocks noChangeAspect="1"/>
+          </p:cNvPicPr>
+          <p:nvPr/>
+        </p:nvPicPr>
+        <p:blipFill>
+          <a:blip r:embed="rId10">
+            <a:alphaModFix/>
+            <a:extLst>
+              <a:ext uri="{96DAC541-7B7A-43D3-8B79-37D633B846F1}">
+                <asvg:svgBlip xmlns:asvg="http://schemas.microsoft.com/office/drawing/2016/SVG/main" r:embed="rId16"/>
+              </a:ext>
+            </a:extLst>
+          </a:blip>
+          <a:stretch>
+            <a:fillRect/>
+          </a:stretch>
+        </p:blipFill>
+        <p:spPr>
+          <a:xfrm>
+            <a:off x="9815059" y="4871611"/>
+            <a:ext cx="1358960" cy="1440000"/>
+          </a:xfrm>
+          <a:prstGeom prst="rect">
+            <a:avLst/>
+          </a:prstGeom>
+          <a:effectLst>
+            <a:glow rad="368300">
+              <a:schemeClr val="tx1"/>
+            </a:glow>
+          </a:effectLst>
+        </p:spPr>
+      </p:pic>
+    </p:spTree>
+    <p:extLst>
+      <p:ext uri="{BB962C8B-B14F-4D97-AF65-F5344CB8AC3E}">
+        <p14:creationId xmlns:p14="http://schemas.microsoft.com/office/powerpoint/2010/main" val="2982037225"/>
+      </p:ext>
+    </p:extLst>
+  </p:cSld>
+  <p:clrMapOvr>
+    <a:masterClrMapping/>
+  </p:clrMapOvr>
+</p:sld>
+</file>
+
+<file path=ppt/slides/slide2.xml><?xml version="1.0" encoding="utf-8"?>
+<p:sld xmlns:a="http://schemas.openxmlformats.org/drawingml/2006/main" xmlns:r="http://schemas.openxmlformats.org/officeDocument/2006/relationships" xmlns:p="http://schemas.openxmlformats.org/presentationml/2006/main">
+  <p:cSld>
     <p:bg>
       <p:bgPr>
         <a:solidFill>
@@ -11001,7 +11632,7 @@
 </p:sld>
 </file>
 
-<file path=ppt/slides/slide2.xml><?xml version="1.0" encoding="utf-8"?>
+<file path=ppt/slides/slide3.xml><?xml version="1.0" encoding="utf-8"?>
 <p:sld xmlns:a="http://schemas.openxmlformats.org/drawingml/2006/main" xmlns:r="http://schemas.openxmlformats.org/officeDocument/2006/relationships" xmlns:p="http://schemas.openxmlformats.org/presentationml/2006/main">
   <p:cSld>
     <p:bg>

</xml_diff>

<commit_message>
Update SVG icons for dark and light modes, and modify sprites UI file
- Replaced the `modedark.svg` icon with a new design featuring updated dimensions and paths.
- Updated the `modelight.svg` icon with a new design and adjusted dimensions.
- Modified the `sprites-ui.svg` file to include the new SVG paths for `modedark` and `modelight` symbols.
- Updated the binary `bcpst.pptx` file.
</commit_message>
<xml_diff>
--- a/Icons_UI/bcpst.pptx
+++ b/Icons_UI/bcpst.pptx
@@ -8,6 +8,7 @@
     <p:sldId id="258" r:id="rId2"/>
     <p:sldId id="257" r:id="rId3"/>
     <p:sldId id="256" r:id="rId4"/>
+    <p:sldId id="259" r:id="rId5"/>
   </p:sldIdLst>
   <p:sldSz cx="12192000" cy="6858000"/>
   <p:notesSz cx="6858000" cy="9144000"/>
@@ -20695,6 +20696,1700 @@
 </p:sld>
 </file>
 
+<file path=ppt/slides/slide4.xml><?xml version="1.0" encoding="utf-8"?>
+<p:sld xmlns:a="http://schemas.openxmlformats.org/drawingml/2006/main" xmlns:r="http://schemas.openxmlformats.org/officeDocument/2006/relationships" xmlns:p="http://schemas.openxmlformats.org/presentationml/2006/main">
+  <p:cSld>
+    <p:spTree>
+      <p:nvGrpSpPr>
+        <p:cNvPr id="1" name=""/>
+        <p:cNvGrpSpPr/>
+        <p:nvPr/>
+      </p:nvGrpSpPr>
+      <p:grpSpPr>
+        <a:xfrm>
+          <a:off x="0" y="0"/>
+          <a:ext cx="0" cy="0"/>
+          <a:chOff x="0" y="0"/>
+          <a:chExt cx="0" cy="0"/>
+        </a:xfrm>
+      </p:grpSpPr>
+      <p:grpSp>
+        <p:nvGrpSpPr>
+          <p:cNvPr id="49" name="Group 48">
+            <a:extLst>
+              <a:ext uri="{FF2B5EF4-FFF2-40B4-BE49-F238E27FC236}">
+                <a16:creationId xmlns:a16="http://schemas.microsoft.com/office/drawing/2014/main" id="{6D069D2A-1855-CB1E-2758-F3608123E3A4}"/>
+              </a:ext>
+            </a:extLst>
+          </p:cNvPr>
+          <p:cNvGrpSpPr/>
+          <p:nvPr/>
+        </p:nvGrpSpPr>
+        <p:grpSpPr>
+          <a:xfrm>
+            <a:off x="759600" y="293525"/>
+            <a:ext cx="1500000" cy="1500000"/>
+            <a:chOff x="759600" y="293525"/>
+            <a:chExt cx="1500000" cy="1500000"/>
+          </a:xfrm>
+        </p:grpSpPr>
+        <p:sp>
+          <p:nvSpPr>
+            <p:cNvPr id="22" name="Freeform: Shape 21">
+              <a:extLst>
+                <a:ext uri="{FF2B5EF4-FFF2-40B4-BE49-F238E27FC236}">
+                  <a16:creationId xmlns:a16="http://schemas.microsoft.com/office/drawing/2014/main" id="{B52F5A64-879F-C768-28E0-D3B56EACF34F}"/>
+                </a:ext>
+              </a:extLst>
+            </p:cNvPr>
+            <p:cNvSpPr/>
+            <p:nvPr/>
+          </p:nvSpPr>
+          <p:spPr>
+            <a:xfrm>
+              <a:off x="1434600" y="293525"/>
+              <a:ext cx="150000" cy="225000"/>
+            </a:xfrm>
+            <a:custGeom>
+              <a:avLst/>
+              <a:gdLst>
+                <a:gd name="csX0" fmla="*/ 75000 w 150000"/>
+                <a:gd name="csY0" fmla="*/ 0 h 225000"/>
+                <a:gd name="csX1" fmla="*/ 150000 w 150000"/>
+                <a:gd name="csY1" fmla="*/ 75000 h 225000"/>
+                <a:gd name="csX2" fmla="*/ 150000 w 150000"/>
+                <a:gd name="csY2" fmla="*/ 150000 h 225000"/>
+                <a:gd name="csX3" fmla="*/ 75000 w 150000"/>
+                <a:gd name="csY3" fmla="*/ 225000 h 225000"/>
+                <a:gd name="csX4" fmla="*/ 0 w 150000"/>
+                <a:gd name="csY4" fmla="*/ 150000 h 225000"/>
+                <a:gd name="csX5" fmla="*/ 0 w 150000"/>
+                <a:gd name="csY5" fmla="*/ 75000 h 225000"/>
+                <a:gd name="csX6" fmla="*/ 75000 w 150000"/>
+                <a:gd name="csY6" fmla="*/ 0 h 225000"/>
+              </a:gdLst>
+              <a:ahLst/>
+              <a:cxnLst>
+                <a:cxn ang="0">
+                  <a:pos x="csX0" y="csY0"/>
+                </a:cxn>
+                <a:cxn ang="0">
+                  <a:pos x="csX1" y="csY1"/>
+                </a:cxn>
+                <a:cxn ang="0">
+                  <a:pos x="csX2" y="csY2"/>
+                </a:cxn>
+                <a:cxn ang="0">
+                  <a:pos x="csX3" y="csY3"/>
+                </a:cxn>
+                <a:cxn ang="0">
+                  <a:pos x="csX4" y="csY4"/>
+                </a:cxn>
+                <a:cxn ang="0">
+                  <a:pos x="csX5" y="csY5"/>
+                </a:cxn>
+                <a:cxn ang="0">
+                  <a:pos x="csX6" y="csY6"/>
+                </a:cxn>
+              </a:cxnLst>
+              <a:rect l="l" t="t" r="r" b="b"/>
+              <a:pathLst>
+                <a:path w="150000" h="225000">
+                  <a:moveTo>
+                    <a:pt x="75000" y="0"/>
+                  </a:moveTo>
+                  <a:cubicBezTo>
+                    <a:pt x="116423" y="0"/>
+                    <a:pt x="150000" y="33579"/>
+                    <a:pt x="150000" y="75000"/>
+                  </a:cubicBezTo>
+                  <a:lnTo>
+                    <a:pt x="150000" y="150000"/>
+                  </a:lnTo>
+                  <a:cubicBezTo>
+                    <a:pt x="150000" y="191421"/>
+                    <a:pt x="116423" y="225000"/>
+                    <a:pt x="75000" y="225000"/>
+                  </a:cubicBezTo>
+                  <a:cubicBezTo>
+                    <a:pt x="33577" y="225000"/>
+                    <a:pt x="0" y="191421"/>
+                    <a:pt x="0" y="150000"/>
+                  </a:cubicBezTo>
+                  <a:lnTo>
+                    <a:pt x="0" y="75000"/>
+                  </a:lnTo>
+                  <a:cubicBezTo>
+                    <a:pt x="0" y="33579"/>
+                    <a:pt x="33577" y="0"/>
+                    <a:pt x="75000" y="0"/>
+                  </a:cubicBezTo>
+                  <a:close/>
+                </a:path>
+              </a:pathLst>
+            </a:custGeom>
+            <a:solidFill>
+              <a:srgbClr val="000000"/>
+            </a:solidFill>
+            <a:ln w="74613" cap="flat">
+              <a:noFill/>
+              <a:prstDash val="solid"/>
+              <a:miter/>
+            </a:ln>
+          </p:spPr>
+          <p:txBody>
+            <a:bodyPr/>
+            <a:lstStyle/>
+            <a:p>
+              <a:endParaRPr lang="en-US"/>
+            </a:p>
+          </p:txBody>
+        </p:sp>
+        <p:sp>
+          <p:nvSpPr>
+            <p:cNvPr id="38" name="Freeform: Shape 37">
+              <a:extLst>
+                <a:ext uri="{FF2B5EF4-FFF2-40B4-BE49-F238E27FC236}">
+                  <a16:creationId xmlns:a16="http://schemas.microsoft.com/office/drawing/2014/main" id="{614CA2FD-7C2B-17F3-8843-B1A04E6EFBB7}"/>
+                </a:ext>
+              </a:extLst>
+            </p:cNvPr>
+            <p:cNvSpPr/>
+            <p:nvPr/>
+          </p:nvSpPr>
+          <p:spPr>
+            <a:xfrm>
+              <a:off x="1059600" y="593525"/>
+              <a:ext cx="900000" cy="900000"/>
+            </a:xfrm>
+            <a:custGeom>
+              <a:avLst/>
+              <a:gdLst>
+                <a:gd name="csX0" fmla="*/ 450000 w 900000"/>
+                <a:gd name="csY0" fmla="*/ 124306 h 900000"/>
+                <a:gd name="csX1" fmla="*/ 124306 w 900000"/>
+                <a:gd name="csY1" fmla="*/ 450000 h 900000"/>
+                <a:gd name="csX2" fmla="*/ 450000 w 900000"/>
+                <a:gd name="csY2" fmla="*/ 775694 h 900000"/>
+                <a:gd name="csX3" fmla="*/ 775694 w 900000"/>
+                <a:gd name="csY3" fmla="*/ 450000 h 900000"/>
+                <a:gd name="csX4" fmla="*/ 450000 w 900000"/>
+                <a:gd name="csY4" fmla="*/ 124306 h 900000"/>
+                <a:gd name="csX5" fmla="*/ 450000 w 900000"/>
+                <a:gd name="csY5" fmla="*/ 0 h 900000"/>
+                <a:gd name="csX6" fmla="*/ 900000 w 900000"/>
+                <a:gd name="csY6" fmla="*/ 450000 h 900000"/>
+                <a:gd name="csX7" fmla="*/ 450000 w 900000"/>
+                <a:gd name="csY7" fmla="*/ 900000 h 900000"/>
+                <a:gd name="csX8" fmla="*/ 0 w 900000"/>
+                <a:gd name="csY8" fmla="*/ 450000 h 900000"/>
+                <a:gd name="csX9" fmla="*/ 450000 w 900000"/>
+                <a:gd name="csY9" fmla="*/ 0 h 900000"/>
+              </a:gdLst>
+              <a:ahLst/>
+              <a:cxnLst>
+                <a:cxn ang="0">
+                  <a:pos x="csX0" y="csY0"/>
+                </a:cxn>
+                <a:cxn ang="0">
+                  <a:pos x="csX1" y="csY1"/>
+                </a:cxn>
+                <a:cxn ang="0">
+                  <a:pos x="csX2" y="csY2"/>
+                </a:cxn>
+                <a:cxn ang="0">
+                  <a:pos x="csX3" y="csY3"/>
+                </a:cxn>
+                <a:cxn ang="0">
+                  <a:pos x="csX4" y="csY4"/>
+                </a:cxn>
+                <a:cxn ang="0">
+                  <a:pos x="csX5" y="csY5"/>
+                </a:cxn>
+                <a:cxn ang="0">
+                  <a:pos x="csX6" y="csY6"/>
+                </a:cxn>
+                <a:cxn ang="0">
+                  <a:pos x="csX7" y="csY7"/>
+                </a:cxn>
+                <a:cxn ang="0">
+                  <a:pos x="csX8" y="csY8"/>
+                </a:cxn>
+                <a:cxn ang="0">
+                  <a:pos x="csX9" y="csY9"/>
+                </a:cxn>
+              </a:cxnLst>
+              <a:rect l="l" t="t" r="r" b="b"/>
+              <a:pathLst>
+                <a:path w="900000" h="900000">
+                  <a:moveTo>
+                    <a:pt x="450000" y="124306"/>
+                  </a:moveTo>
+                  <a:cubicBezTo>
+                    <a:pt x="270125" y="124306"/>
+                    <a:pt x="124306" y="270124"/>
+                    <a:pt x="124306" y="450000"/>
+                  </a:cubicBezTo>
+                  <a:cubicBezTo>
+                    <a:pt x="124306" y="629876"/>
+                    <a:pt x="270125" y="775694"/>
+                    <a:pt x="450000" y="775694"/>
+                  </a:cubicBezTo>
+                  <a:cubicBezTo>
+                    <a:pt x="629876" y="775694"/>
+                    <a:pt x="775694" y="629876"/>
+                    <a:pt x="775694" y="450000"/>
+                  </a:cubicBezTo>
+                  <a:cubicBezTo>
+                    <a:pt x="775694" y="270124"/>
+                    <a:pt x="629876" y="124306"/>
+                    <a:pt x="450000" y="124306"/>
+                  </a:cubicBezTo>
+                  <a:close/>
+                  <a:moveTo>
+                    <a:pt x="450000" y="0"/>
+                  </a:moveTo>
+                  <a:cubicBezTo>
+                    <a:pt x="698528" y="0"/>
+                    <a:pt x="900000" y="201472"/>
+                    <a:pt x="900000" y="450000"/>
+                  </a:cubicBezTo>
+                  <a:cubicBezTo>
+                    <a:pt x="900000" y="698528"/>
+                    <a:pt x="698528" y="900000"/>
+                    <a:pt x="450000" y="900000"/>
+                  </a:cubicBezTo>
+                  <a:cubicBezTo>
+                    <a:pt x="201472" y="900000"/>
+                    <a:pt x="0" y="698528"/>
+                    <a:pt x="0" y="450000"/>
+                  </a:cubicBezTo>
+                  <a:cubicBezTo>
+                    <a:pt x="0" y="201472"/>
+                    <a:pt x="201472" y="0"/>
+                    <a:pt x="450000" y="0"/>
+                  </a:cubicBezTo>
+                  <a:close/>
+                </a:path>
+              </a:pathLst>
+            </a:custGeom>
+            <a:solidFill>
+              <a:srgbClr val="000000"/>
+            </a:solidFill>
+            <a:ln w="74613" cap="flat">
+              <a:noFill/>
+              <a:prstDash val="solid"/>
+              <a:miter/>
+            </a:ln>
+          </p:spPr>
+          <p:txBody>
+            <a:bodyPr wrap="square">
+              <a:noAutofit/>
+            </a:bodyPr>
+            <a:lstStyle/>
+            <a:p>
+              <a:endParaRPr lang="en-US"/>
+            </a:p>
+          </p:txBody>
+        </p:sp>
+        <p:sp>
+          <p:nvSpPr>
+            <p:cNvPr id="24" name="Freeform: Shape 23">
+              <a:extLst>
+                <a:ext uri="{FF2B5EF4-FFF2-40B4-BE49-F238E27FC236}">
+                  <a16:creationId xmlns:a16="http://schemas.microsoft.com/office/drawing/2014/main" id="{8B4BBF9B-402C-3079-F298-CFE0F242F85E}"/>
+                </a:ext>
+              </a:extLst>
+            </p:cNvPr>
+            <p:cNvSpPr/>
+            <p:nvPr/>
+          </p:nvSpPr>
+          <p:spPr>
+            <a:xfrm>
+              <a:off x="1434600" y="1568525"/>
+              <a:ext cx="150000" cy="225000"/>
+            </a:xfrm>
+            <a:custGeom>
+              <a:avLst/>
+              <a:gdLst>
+                <a:gd name="csX0" fmla="*/ 150000 w 150000"/>
+                <a:gd name="csY0" fmla="*/ 75000 h 225000"/>
+                <a:gd name="csX1" fmla="*/ 75000 w 150000"/>
+                <a:gd name="csY1" fmla="*/ 0 h 225000"/>
+                <a:gd name="csX2" fmla="*/ 0 w 150000"/>
+                <a:gd name="csY2" fmla="*/ 75000 h 225000"/>
+                <a:gd name="csX3" fmla="*/ 0 w 150000"/>
+                <a:gd name="csY3" fmla="*/ 150000 h 225000"/>
+                <a:gd name="csX4" fmla="*/ 75000 w 150000"/>
+                <a:gd name="csY4" fmla="*/ 225000 h 225000"/>
+                <a:gd name="csX5" fmla="*/ 150000 w 150000"/>
+                <a:gd name="csY5" fmla="*/ 150000 h 225000"/>
+              </a:gdLst>
+              <a:ahLst/>
+              <a:cxnLst>
+                <a:cxn ang="0">
+                  <a:pos x="csX0" y="csY0"/>
+                </a:cxn>
+                <a:cxn ang="0">
+                  <a:pos x="csX1" y="csY1"/>
+                </a:cxn>
+                <a:cxn ang="0">
+                  <a:pos x="csX2" y="csY2"/>
+                </a:cxn>
+                <a:cxn ang="0">
+                  <a:pos x="csX3" y="csY3"/>
+                </a:cxn>
+                <a:cxn ang="0">
+                  <a:pos x="csX4" y="csY4"/>
+                </a:cxn>
+                <a:cxn ang="0">
+                  <a:pos x="csX5" y="csY5"/>
+                </a:cxn>
+              </a:cxnLst>
+              <a:rect l="l" t="t" r="r" b="b"/>
+              <a:pathLst>
+                <a:path w="150000" h="225000">
+                  <a:moveTo>
+                    <a:pt x="150000" y="75000"/>
+                  </a:moveTo>
+                  <a:cubicBezTo>
+                    <a:pt x="150000" y="33578"/>
+                    <a:pt x="116423" y="0"/>
+                    <a:pt x="75000" y="0"/>
+                  </a:cubicBezTo>
+                  <a:cubicBezTo>
+                    <a:pt x="33577" y="0"/>
+                    <a:pt x="0" y="33578"/>
+                    <a:pt x="0" y="75000"/>
+                  </a:cubicBezTo>
+                  <a:lnTo>
+                    <a:pt x="0" y="150000"/>
+                  </a:lnTo>
+                  <a:cubicBezTo>
+                    <a:pt x="0" y="191422"/>
+                    <a:pt x="33577" y="225000"/>
+                    <a:pt x="75000" y="225000"/>
+                  </a:cubicBezTo>
+                  <a:cubicBezTo>
+                    <a:pt x="116423" y="225000"/>
+                    <a:pt x="150000" y="191422"/>
+                    <a:pt x="150000" y="150000"/>
+                  </a:cubicBezTo>
+                  <a:close/>
+                </a:path>
+              </a:pathLst>
+            </a:custGeom>
+            <a:solidFill>
+              <a:srgbClr val="000000"/>
+            </a:solidFill>
+            <a:ln w="74613" cap="flat">
+              <a:noFill/>
+              <a:prstDash val="solid"/>
+              <a:miter/>
+            </a:ln>
+          </p:spPr>
+          <p:txBody>
+            <a:bodyPr/>
+            <a:lstStyle/>
+            <a:p>
+              <a:endParaRPr lang="en-US"/>
+            </a:p>
+          </p:txBody>
+        </p:sp>
+        <p:sp>
+          <p:nvSpPr>
+            <p:cNvPr id="25" name="Freeform: Shape 24">
+              <a:extLst>
+                <a:ext uri="{FF2B5EF4-FFF2-40B4-BE49-F238E27FC236}">
+                  <a16:creationId xmlns:a16="http://schemas.microsoft.com/office/drawing/2014/main" id="{95888366-DFD7-6E5D-E6FA-F5DF4A019DBB}"/>
+                </a:ext>
+              </a:extLst>
+            </p:cNvPr>
+            <p:cNvSpPr/>
+            <p:nvPr/>
+          </p:nvSpPr>
+          <p:spPr>
+            <a:xfrm>
+              <a:off x="2034600" y="968525"/>
+              <a:ext cx="225000" cy="150000"/>
+            </a:xfrm>
+            <a:custGeom>
+              <a:avLst/>
+              <a:gdLst>
+                <a:gd name="csX0" fmla="*/ 225000 w 225000"/>
+                <a:gd name="csY0" fmla="*/ 75000 h 150000"/>
+                <a:gd name="csX1" fmla="*/ 150000 w 225000"/>
+                <a:gd name="csY1" fmla="*/ 150000 h 150000"/>
+                <a:gd name="csX2" fmla="*/ 75000 w 225000"/>
+                <a:gd name="csY2" fmla="*/ 150000 h 150000"/>
+                <a:gd name="csX3" fmla="*/ 0 w 225000"/>
+                <a:gd name="csY3" fmla="*/ 75000 h 150000"/>
+                <a:gd name="csX4" fmla="*/ 75000 w 225000"/>
+                <a:gd name="csY4" fmla="*/ 0 h 150000"/>
+                <a:gd name="csX5" fmla="*/ 150000 w 225000"/>
+                <a:gd name="csY5" fmla="*/ 0 h 150000"/>
+                <a:gd name="csX6" fmla="*/ 225000 w 225000"/>
+                <a:gd name="csY6" fmla="*/ 75000 h 150000"/>
+              </a:gdLst>
+              <a:ahLst/>
+              <a:cxnLst>
+                <a:cxn ang="0">
+                  <a:pos x="csX0" y="csY0"/>
+                </a:cxn>
+                <a:cxn ang="0">
+                  <a:pos x="csX1" y="csY1"/>
+                </a:cxn>
+                <a:cxn ang="0">
+                  <a:pos x="csX2" y="csY2"/>
+                </a:cxn>
+                <a:cxn ang="0">
+                  <a:pos x="csX3" y="csY3"/>
+                </a:cxn>
+                <a:cxn ang="0">
+                  <a:pos x="csX4" y="csY4"/>
+                </a:cxn>
+                <a:cxn ang="0">
+                  <a:pos x="csX5" y="csY5"/>
+                </a:cxn>
+                <a:cxn ang="0">
+                  <a:pos x="csX6" y="csY6"/>
+                </a:cxn>
+              </a:cxnLst>
+              <a:rect l="l" t="t" r="r" b="b"/>
+              <a:pathLst>
+                <a:path w="225000" h="150000">
+                  <a:moveTo>
+                    <a:pt x="225000" y="75000"/>
+                  </a:moveTo>
+                  <a:cubicBezTo>
+                    <a:pt x="225000" y="116423"/>
+                    <a:pt x="191422" y="150000"/>
+                    <a:pt x="150000" y="150000"/>
+                  </a:cubicBezTo>
+                  <a:lnTo>
+                    <a:pt x="75000" y="150000"/>
+                  </a:lnTo>
+                  <a:cubicBezTo>
+                    <a:pt x="33578" y="150000"/>
+                    <a:pt x="0" y="116423"/>
+                    <a:pt x="0" y="75000"/>
+                  </a:cubicBezTo>
+                  <a:cubicBezTo>
+                    <a:pt x="0" y="33577"/>
+                    <a:pt x="33578" y="0"/>
+                    <a:pt x="75000" y="0"/>
+                  </a:cubicBezTo>
+                  <a:lnTo>
+                    <a:pt x="150000" y="0"/>
+                  </a:lnTo>
+                  <a:cubicBezTo>
+                    <a:pt x="191422" y="0"/>
+                    <a:pt x="225000" y="33577"/>
+                    <a:pt x="225000" y="75000"/>
+                  </a:cubicBezTo>
+                  <a:close/>
+                </a:path>
+              </a:pathLst>
+            </a:custGeom>
+            <a:solidFill>
+              <a:srgbClr val="000000"/>
+            </a:solidFill>
+            <a:ln w="74613" cap="flat">
+              <a:noFill/>
+              <a:prstDash val="solid"/>
+              <a:miter/>
+            </a:ln>
+          </p:spPr>
+          <p:txBody>
+            <a:bodyPr/>
+            <a:lstStyle/>
+            <a:p>
+              <a:endParaRPr lang="en-US"/>
+            </a:p>
+          </p:txBody>
+        </p:sp>
+        <p:sp>
+          <p:nvSpPr>
+            <p:cNvPr id="26" name="Freeform: Shape 25">
+              <a:extLst>
+                <a:ext uri="{FF2B5EF4-FFF2-40B4-BE49-F238E27FC236}">
+                  <a16:creationId xmlns:a16="http://schemas.microsoft.com/office/drawing/2014/main" id="{0AAFEEE1-EF3F-5C43-C379-AA27E42FFA06}"/>
+                </a:ext>
+              </a:extLst>
+            </p:cNvPr>
+            <p:cNvSpPr/>
+            <p:nvPr/>
+          </p:nvSpPr>
+          <p:spPr>
+            <a:xfrm>
+              <a:off x="759600" y="968525"/>
+              <a:ext cx="225000" cy="150000"/>
+            </a:xfrm>
+            <a:custGeom>
+              <a:avLst/>
+              <a:gdLst>
+                <a:gd name="csX0" fmla="*/ 150000 w 225000"/>
+                <a:gd name="csY0" fmla="*/ 150000 h 150000"/>
+                <a:gd name="csX1" fmla="*/ 225000 w 225000"/>
+                <a:gd name="csY1" fmla="*/ 75000 h 150000"/>
+                <a:gd name="csX2" fmla="*/ 150000 w 225000"/>
+                <a:gd name="csY2" fmla="*/ 0 h 150000"/>
+                <a:gd name="csX3" fmla="*/ 75000 w 225000"/>
+                <a:gd name="csY3" fmla="*/ 0 h 150000"/>
+                <a:gd name="csX4" fmla="*/ 0 w 225000"/>
+                <a:gd name="csY4" fmla="*/ 75000 h 150000"/>
+                <a:gd name="csX5" fmla="*/ 75000 w 225000"/>
+                <a:gd name="csY5" fmla="*/ 150000 h 150000"/>
+              </a:gdLst>
+              <a:ahLst/>
+              <a:cxnLst>
+                <a:cxn ang="0">
+                  <a:pos x="csX0" y="csY0"/>
+                </a:cxn>
+                <a:cxn ang="0">
+                  <a:pos x="csX1" y="csY1"/>
+                </a:cxn>
+                <a:cxn ang="0">
+                  <a:pos x="csX2" y="csY2"/>
+                </a:cxn>
+                <a:cxn ang="0">
+                  <a:pos x="csX3" y="csY3"/>
+                </a:cxn>
+                <a:cxn ang="0">
+                  <a:pos x="csX4" y="csY4"/>
+                </a:cxn>
+                <a:cxn ang="0">
+                  <a:pos x="csX5" y="csY5"/>
+                </a:cxn>
+              </a:cxnLst>
+              <a:rect l="l" t="t" r="r" b="b"/>
+              <a:pathLst>
+                <a:path w="225000" h="150000">
+                  <a:moveTo>
+                    <a:pt x="150000" y="150000"/>
+                  </a:moveTo>
+                  <a:cubicBezTo>
+                    <a:pt x="191421" y="150000"/>
+                    <a:pt x="225000" y="116423"/>
+                    <a:pt x="225000" y="75000"/>
+                  </a:cubicBezTo>
+                  <a:cubicBezTo>
+                    <a:pt x="225000" y="33577"/>
+                    <a:pt x="191421" y="0"/>
+                    <a:pt x="150000" y="0"/>
+                  </a:cubicBezTo>
+                  <a:lnTo>
+                    <a:pt x="75000" y="0"/>
+                  </a:lnTo>
+                  <a:cubicBezTo>
+                    <a:pt x="33579" y="0"/>
+                    <a:pt x="0" y="33577"/>
+                    <a:pt x="0" y="75000"/>
+                  </a:cubicBezTo>
+                  <a:cubicBezTo>
+                    <a:pt x="0" y="116423"/>
+                    <a:pt x="33579" y="150000"/>
+                    <a:pt x="75000" y="150000"/>
+                  </a:cubicBezTo>
+                  <a:close/>
+                </a:path>
+              </a:pathLst>
+            </a:custGeom>
+            <a:solidFill>
+              <a:srgbClr val="000000"/>
+            </a:solidFill>
+            <a:ln w="74613" cap="flat">
+              <a:noFill/>
+              <a:prstDash val="solid"/>
+              <a:miter/>
+            </a:ln>
+          </p:spPr>
+          <p:txBody>
+            <a:bodyPr/>
+            <a:lstStyle/>
+            <a:p>
+              <a:endParaRPr lang="en-US"/>
+            </a:p>
+          </p:txBody>
+        </p:sp>
+        <p:sp>
+          <p:nvSpPr>
+            <p:cNvPr id="27" name="Freeform: Shape 26">
+              <a:extLst>
+                <a:ext uri="{FF2B5EF4-FFF2-40B4-BE49-F238E27FC236}">
+                  <a16:creationId xmlns:a16="http://schemas.microsoft.com/office/drawing/2014/main" id="{A197FA17-EF21-0C3C-E02F-642A97AFDAEA}"/>
+                </a:ext>
+              </a:extLst>
+            </p:cNvPr>
+            <p:cNvSpPr/>
+            <p:nvPr/>
+          </p:nvSpPr>
+          <p:spPr>
+            <a:xfrm>
+              <a:off x="1858863" y="491228"/>
+              <a:ext cx="203034" cy="203033"/>
+            </a:xfrm>
+            <a:custGeom>
+              <a:avLst/>
+              <a:gdLst>
+                <a:gd name="csX0" fmla="*/ 181069 w 203034"/>
+                <a:gd name="csY0" fmla="*/ 128033 h 203033"/>
+                <a:gd name="csX1" fmla="*/ 128036 w 203034"/>
+                <a:gd name="csY1" fmla="*/ 181066 h 203033"/>
+                <a:gd name="csX2" fmla="*/ 21971 w 203034"/>
+                <a:gd name="csY2" fmla="*/ 181066 h 203033"/>
+                <a:gd name="csX3" fmla="*/ 21971 w 203034"/>
+                <a:gd name="csY3" fmla="*/ 75000 h 203033"/>
+                <a:gd name="csX4" fmla="*/ 75004 w 203034"/>
+                <a:gd name="csY4" fmla="*/ 21967 h 203033"/>
+                <a:gd name="csX5" fmla="*/ 181069 w 203034"/>
+                <a:gd name="csY5" fmla="*/ 21967 h 203033"/>
+                <a:gd name="csX6" fmla="*/ 181069 w 203034"/>
+                <a:gd name="csY6" fmla="*/ 128033 h 203033"/>
+              </a:gdLst>
+              <a:ahLst/>
+              <a:cxnLst>
+                <a:cxn ang="0">
+                  <a:pos x="csX0" y="csY0"/>
+                </a:cxn>
+                <a:cxn ang="0">
+                  <a:pos x="csX1" y="csY1"/>
+                </a:cxn>
+                <a:cxn ang="0">
+                  <a:pos x="csX2" y="csY2"/>
+                </a:cxn>
+                <a:cxn ang="0">
+                  <a:pos x="csX3" y="csY3"/>
+                </a:cxn>
+                <a:cxn ang="0">
+                  <a:pos x="csX4" y="csY4"/>
+                </a:cxn>
+                <a:cxn ang="0">
+                  <a:pos x="csX5" y="csY5"/>
+                </a:cxn>
+                <a:cxn ang="0">
+                  <a:pos x="csX6" y="csY6"/>
+                </a:cxn>
+              </a:cxnLst>
+              <a:rect l="l" t="t" r="r" b="b"/>
+              <a:pathLst>
+                <a:path w="203034" h="203033">
+                  <a:moveTo>
+                    <a:pt x="181069" y="128033"/>
+                  </a:moveTo>
+                  <a:lnTo>
+                    <a:pt x="128036" y="181066"/>
+                  </a:lnTo>
+                  <a:cubicBezTo>
+                    <a:pt x="98741" y="210356"/>
+                    <a:pt x="51259" y="210356"/>
+                    <a:pt x="21971" y="181066"/>
+                  </a:cubicBezTo>
+                  <a:cubicBezTo>
+                    <a:pt x="-7324" y="151777"/>
+                    <a:pt x="-7324" y="104289"/>
+                    <a:pt x="21971" y="75000"/>
+                  </a:cubicBezTo>
+                  <a:lnTo>
+                    <a:pt x="75004" y="21967"/>
+                  </a:lnTo>
+                  <a:cubicBezTo>
+                    <a:pt x="104291" y="-7322"/>
+                    <a:pt x="151774" y="-7322"/>
+                    <a:pt x="181069" y="21967"/>
+                  </a:cubicBezTo>
+                  <a:cubicBezTo>
+                    <a:pt x="210356" y="51256"/>
+                    <a:pt x="210356" y="98743"/>
+                    <a:pt x="181069" y="128033"/>
+                  </a:cubicBezTo>
+                  <a:close/>
+                </a:path>
+              </a:pathLst>
+            </a:custGeom>
+            <a:solidFill>
+              <a:srgbClr val="000000"/>
+            </a:solidFill>
+            <a:ln w="74613" cap="flat">
+              <a:noFill/>
+              <a:prstDash val="solid"/>
+              <a:miter/>
+            </a:ln>
+          </p:spPr>
+          <p:txBody>
+            <a:bodyPr/>
+            <a:lstStyle/>
+            <a:p>
+              <a:endParaRPr lang="en-US"/>
+            </a:p>
+          </p:txBody>
+        </p:sp>
+        <p:sp>
+          <p:nvSpPr>
+            <p:cNvPr id="28" name="Freeform: Shape 27">
+              <a:extLst>
+                <a:ext uri="{FF2B5EF4-FFF2-40B4-BE49-F238E27FC236}">
+                  <a16:creationId xmlns:a16="http://schemas.microsoft.com/office/drawing/2014/main" id="{92176164-2296-22B1-0452-261DAB364F5F}"/>
+                </a:ext>
+              </a:extLst>
+            </p:cNvPr>
+            <p:cNvSpPr/>
+            <p:nvPr/>
+          </p:nvSpPr>
+          <p:spPr>
+            <a:xfrm>
+              <a:off x="957302" y="1392786"/>
+              <a:ext cx="203033" cy="203036"/>
+            </a:xfrm>
+            <a:custGeom>
+              <a:avLst/>
+              <a:gdLst>
+                <a:gd name="csX0" fmla="*/ 181066 w 203033"/>
+                <a:gd name="csY0" fmla="*/ 128038 h 203036"/>
+                <a:gd name="csX1" fmla="*/ 181066 w 203033"/>
+                <a:gd name="csY1" fmla="*/ 21966 h 203036"/>
+                <a:gd name="csX2" fmla="*/ 75000 w 203033"/>
+                <a:gd name="csY2" fmla="*/ 21966 h 203036"/>
+                <a:gd name="csX3" fmla="*/ 21967 w 203033"/>
+                <a:gd name="csY3" fmla="*/ 75006 h 203036"/>
+                <a:gd name="csX4" fmla="*/ 21967 w 203033"/>
+                <a:gd name="csY4" fmla="*/ 181071 h 203036"/>
+                <a:gd name="csX5" fmla="*/ 128033 w 203033"/>
+                <a:gd name="csY5" fmla="*/ 181071 h 203036"/>
+              </a:gdLst>
+              <a:ahLst/>
+              <a:cxnLst>
+                <a:cxn ang="0">
+                  <a:pos x="csX0" y="csY0"/>
+                </a:cxn>
+                <a:cxn ang="0">
+                  <a:pos x="csX1" y="csY1"/>
+                </a:cxn>
+                <a:cxn ang="0">
+                  <a:pos x="csX2" y="csY2"/>
+                </a:cxn>
+                <a:cxn ang="0">
+                  <a:pos x="csX3" y="csY3"/>
+                </a:cxn>
+                <a:cxn ang="0">
+                  <a:pos x="csX4" y="csY4"/>
+                </a:cxn>
+                <a:cxn ang="0">
+                  <a:pos x="csX5" y="csY5"/>
+                </a:cxn>
+              </a:cxnLst>
+              <a:rect l="l" t="t" r="r" b="b"/>
+              <a:pathLst>
+                <a:path w="203033" h="203036">
+                  <a:moveTo>
+                    <a:pt x="181066" y="128038"/>
+                  </a:moveTo>
+                  <a:cubicBezTo>
+                    <a:pt x="210355" y="98743"/>
+                    <a:pt x="210355" y="51261"/>
+                    <a:pt x="181066" y="21966"/>
+                  </a:cubicBezTo>
+                  <a:cubicBezTo>
+                    <a:pt x="151777" y="-7322"/>
+                    <a:pt x="104290" y="-7322"/>
+                    <a:pt x="75000" y="21966"/>
+                  </a:cubicBezTo>
+                  <a:lnTo>
+                    <a:pt x="21967" y="75006"/>
+                  </a:lnTo>
+                  <a:cubicBezTo>
+                    <a:pt x="-7322" y="104293"/>
+                    <a:pt x="-7322" y="151776"/>
+                    <a:pt x="21967" y="181071"/>
+                  </a:cubicBezTo>
+                  <a:cubicBezTo>
+                    <a:pt x="51256" y="210358"/>
+                    <a:pt x="98744" y="210358"/>
+                    <a:pt x="128033" y="181071"/>
+                  </a:cubicBezTo>
+                  <a:close/>
+                </a:path>
+              </a:pathLst>
+            </a:custGeom>
+            <a:solidFill>
+              <a:srgbClr val="000000"/>
+            </a:solidFill>
+            <a:ln w="74613" cap="flat">
+              <a:noFill/>
+              <a:prstDash val="solid"/>
+              <a:miter/>
+            </a:ln>
+          </p:spPr>
+          <p:txBody>
+            <a:bodyPr/>
+            <a:lstStyle/>
+            <a:p>
+              <a:endParaRPr lang="en-US"/>
+            </a:p>
+          </p:txBody>
+        </p:sp>
+        <p:sp>
+          <p:nvSpPr>
+            <p:cNvPr id="29" name="Freeform: Shape 28">
+              <a:extLst>
+                <a:ext uri="{FF2B5EF4-FFF2-40B4-BE49-F238E27FC236}">
+                  <a16:creationId xmlns:a16="http://schemas.microsoft.com/office/drawing/2014/main" id="{765E1BF9-A829-F404-54BD-0AC69E768EEB}"/>
+                </a:ext>
+              </a:extLst>
+            </p:cNvPr>
+            <p:cNvSpPr/>
+            <p:nvPr/>
+          </p:nvSpPr>
+          <p:spPr>
+            <a:xfrm>
+              <a:off x="1858863" y="1392786"/>
+              <a:ext cx="203034" cy="203036"/>
+            </a:xfrm>
+            <a:custGeom>
+              <a:avLst/>
+              <a:gdLst>
+                <a:gd name="csX0" fmla="*/ 75004 w 203034"/>
+                <a:gd name="csY0" fmla="*/ 181071 h 203036"/>
+                <a:gd name="csX1" fmla="*/ 21971 w 203034"/>
+                <a:gd name="csY1" fmla="*/ 128038 h 203036"/>
+                <a:gd name="csX2" fmla="*/ 21971 w 203034"/>
+                <a:gd name="csY2" fmla="*/ 21966 h 203036"/>
+                <a:gd name="csX3" fmla="*/ 128036 w 203034"/>
+                <a:gd name="csY3" fmla="*/ 21966 h 203036"/>
+                <a:gd name="csX4" fmla="*/ 181069 w 203034"/>
+                <a:gd name="csY4" fmla="*/ 75006 h 203036"/>
+                <a:gd name="csX5" fmla="*/ 181069 w 203034"/>
+                <a:gd name="csY5" fmla="*/ 181071 h 203036"/>
+                <a:gd name="csX6" fmla="*/ 75004 w 203034"/>
+                <a:gd name="csY6" fmla="*/ 181071 h 203036"/>
+              </a:gdLst>
+              <a:ahLst/>
+              <a:cxnLst>
+                <a:cxn ang="0">
+                  <a:pos x="csX0" y="csY0"/>
+                </a:cxn>
+                <a:cxn ang="0">
+                  <a:pos x="csX1" y="csY1"/>
+                </a:cxn>
+                <a:cxn ang="0">
+                  <a:pos x="csX2" y="csY2"/>
+                </a:cxn>
+                <a:cxn ang="0">
+                  <a:pos x="csX3" y="csY3"/>
+                </a:cxn>
+                <a:cxn ang="0">
+                  <a:pos x="csX4" y="csY4"/>
+                </a:cxn>
+                <a:cxn ang="0">
+                  <a:pos x="csX5" y="csY5"/>
+                </a:cxn>
+                <a:cxn ang="0">
+                  <a:pos x="csX6" y="csY6"/>
+                </a:cxn>
+              </a:cxnLst>
+              <a:rect l="l" t="t" r="r" b="b"/>
+              <a:pathLst>
+                <a:path w="203034" h="203036">
+                  <a:moveTo>
+                    <a:pt x="75004" y="181071"/>
+                  </a:moveTo>
+                  <a:lnTo>
+                    <a:pt x="21971" y="128038"/>
+                  </a:lnTo>
+                  <a:cubicBezTo>
+                    <a:pt x="-7324" y="98743"/>
+                    <a:pt x="-7324" y="51261"/>
+                    <a:pt x="21971" y="21966"/>
+                  </a:cubicBezTo>
+                  <a:cubicBezTo>
+                    <a:pt x="51259" y="-7322"/>
+                    <a:pt x="98741" y="-7322"/>
+                    <a:pt x="128036" y="21966"/>
+                  </a:cubicBezTo>
+                  <a:lnTo>
+                    <a:pt x="181069" y="75006"/>
+                  </a:lnTo>
+                  <a:cubicBezTo>
+                    <a:pt x="210356" y="104293"/>
+                    <a:pt x="210356" y="151776"/>
+                    <a:pt x="181069" y="181071"/>
+                  </a:cubicBezTo>
+                  <a:cubicBezTo>
+                    <a:pt x="151781" y="210358"/>
+                    <a:pt x="104291" y="210358"/>
+                    <a:pt x="75004" y="181071"/>
+                  </a:cubicBezTo>
+                  <a:close/>
+                </a:path>
+              </a:pathLst>
+            </a:custGeom>
+            <a:solidFill>
+              <a:srgbClr val="000000"/>
+            </a:solidFill>
+            <a:ln w="74613" cap="flat">
+              <a:noFill/>
+              <a:prstDash val="solid"/>
+              <a:miter/>
+            </a:ln>
+          </p:spPr>
+          <p:txBody>
+            <a:bodyPr/>
+            <a:lstStyle/>
+            <a:p>
+              <a:endParaRPr lang="en-US"/>
+            </a:p>
+          </p:txBody>
+        </p:sp>
+        <p:sp>
+          <p:nvSpPr>
+            <p:cNvPr id="30" name="Freeform: Shape 29">
+              <a:extLst>
+                <a:ext uri="{FF2B5EF4-FFF2-40B4-BE49-F238E27FC236}">
+                  <a16:creationId xmlns:a16="http://schemas.microsoft.com/office/drawing/2014/main" id="{17180D62-5E12-EB0C-ACB8-D6EBADECF2D0}"/>
+                </a:ext>
+              </a:extLst>
+            </p:cNvPr>
+            <p:cNvSpPr/>
+            <p:nvPr/>
+          </p:nvSpPr>
+          <p:spPr>
+            <a:xfrm>
+              <a:off x="957302" y="491228"/>
+              <a:ext cx="203033" cy="203033"/>
+            </a:xfrm>
+            <a:custGeom>
+              <a:avLst/>
+              <a:gdLst>
+                <a:gd name="csX0" fmla="*/ 75000 w 203033"/>
+                <a:gd name="csY0" fmla="*/ 181066 h 203033"/>
+                <a:gd name="csX1" fmla="*/ 181066 w 203033"/>
+                <a:gd name="csY1" fmla="*/ 181066 h 203033"/>
+                <a:gd name="csX2" fmla="*/ 181066 w 203033"/>
+                <a:gd name="csY2" fmla="*/ 75000 h 203033"/>
+                <a:gd name="csX3" fmla="*/ 128033 w 203033"/>
+                <a:gd name="csY3" fmla="*/ 21967 h 203033"/>
+                <a:gd name="csX4" fmla="*/ 21967 w 203033"/>
+                <a:gd name="csY4" fmla="*/ 21967 h 203033"/>
+                <a:gd name="csX5" fmla="*/ 21967 w 203033"/>
+                <a:gd name="csY5" fmla="*/ 128033 h 203033"/>
+              </a:gdLst>
+              <a:ahLst/>
+              <a:cxnLst>
+                <a:cxn ang="0">
+                  <a:pos x="csX0" y="csY0"/>
+                </a:cxn>
+                <a:cxn ang="0">
+                  <a:pos x="csX1" y="csY1"/>
+                </a:cxn>
+                <a:cxn ang="0">
+                  <a:pos x="csX2" y="csY2"/>
+                </a:cxn>
+                <a:cxn ang="0">
+                  <a:pos x="csX3" y="csY3"/>
+                </a:cxn>
+                <a:cxn ang="0">
+                  <a:pos x="csX4" y="csY4"/>
+                </a:cxn>
+                <a:cxn ang="0">
+                  <a:pos x="csX5" y="csY5"/>
+                </a:cxn>
+              </a:cxnLst>
+              <a:rect l="l" t="t" r="r" b="b"/>
+              <a:pathLst>
+                <a:path w="203033" h="203033">
+                  <a:moveTo>
+                    <a:pt x="75000" y="181066"/>
+                  </a:moveTo>
+                  <a:cubicBezTo>
+                    <a:pt x="104290" y="210356"/>
+                    <a:pt x="151777" y="210356"/>
+                    <a:pt x="181066" y="181066"/>
+                  </a:cubicBezTo>
+                  <a:cubicBezTo>
+                    <a:pt x="210355" y="151777"/>
+                    <a:pt x="210355" y="104289"/>
+                    <a:pt x="181066" y="75000"/>
+                  </a:cubicBezTo>
+                  <a:lnTo>
+                    <a:pt x="128033" y="21967"/>
+                  </a:lnTo>
+                  <a:cubicBezTo>
+                    <a:pt x="98744" y="-7322"/>
+                    <a:pt x="51256" y="-7322"/>
+                    <a:pt x="21967" y="21967"/>
+                  </a:cubicBezTo>
+                  <a:cubicBezTo>
+                    <a:pt x="-7322" y="51256"/>
+                    <a:pt x="-7322" y="98743"/>
+                    <a:pt x="21967" y="128033"/>
+                  </a:cubicBezTo>
+                  <a:close/>
+                </a:path>
+              </a:pathLst>
+            </a:custGeom>
+            <a:solidFill>
+              <a:srgbClr val="000000"/>
+            </a:solidFill>
+            <a:ln w="74613" cap="flat">
+              <a:noFill/>
+              <a:prstDash val="solid"/>
+              <a:miter/>
+            </a:ln>
+          </p:spPr>
+          <p:txBody>
+            <a:bodyPr/>
+            <a:lstStyle/>
+            <a:p>
+              <a:endParaRPr lang="en-US"/>
+            </a:p>
+          </p:txBody>
+        </p:sp>
+      </p:grpSp>
+      <p:sp>
+        <p:nvSpPr>
+          <p:cNvPr id="35" name="Freeform: Shape 34">
+            <a:extLst>
+              <a:ext uri="{FF2B5EF4-FFF2-40B4-BE49-F238E27FC236}">
+                <a16:creationId xmlns:a16="http://schemas.microsoft.com/office/drawing/2014/main" id="{DBFFE6FC-20FA-BDB9-9377-208B24B8D088}"/>
+              </a:ext>
+            </a:extLst>
+          </p:cNvPr>
+          <p:cNvSpPr/>
+          <p:nvPr/>
+        </p:nvSpPr>
+        <p:spPr>
+          <a:xfrm rot="19319567">
+            <a:off x="3611767" y="675989"/>
+            <a:ext cx="627137" cy="900000"/>
+          </a:xfrm>
+          <a:custGeom>
+            <a:avLst/>
+            <a:gdLst>
+              <a:gd name="csX0" fmla="*/ 450000 w 645150"/>
+              <a:gd name="csY0" fmla="*/ 0 h 900000"/>
+              <a:gd name="csX1" fmla="*/ 625161 w 645150"/>
+              <a:gd name="csY1" fmla="*/ 35364 h 900000"/>
+              <a:gd name="csX2" fmla="*/ 645150 w 645150"/>
+              <a:gd name="csY2" fmla="*/ 46214 h 900000"/>
+              <a:gd name="csX3" fmla="*/ 588701 w 645150"/>
+              <a:gd name="csY3" fmla="*/ 76853 h 900000"/>
+              <a:gd name="csX4" fmla="*/ 390300 w 645150"/>
+              <a:gd name="csY4" fmla="*/ 450000 h 900000"/>
+              <a:gd name="csX5" fmla="*/ 588701 w 645150"/>
+              <a:gd name="csY5" fmla="*/ 823147 h 900000"/>
+              <a:gd name="csX6" fmla="*/ 645150 w 645150"/>
+              <a:gd name="csY6" fmla="*/ 853787 h 900000"/>
+              <a:gd name="csX7" fmla="*/ 625161 w 645150"/>
+              <a:gd name="csY7" fmla="*/ 864637 h 900000"/>
+              <a:gd name="csX8" fmla="*/ 450000 w 645150"/>
+              <a:gd name="csY8" fmla="*/ 900000 h 900000"/>
+              <a:gd name="csX9" fmla="*/ 0 w 645150"/>
+              <a:gd name="csY9" fmla="*/ 450000 h 900000"/>
+              <a:gd name="csX10" fmla="*/ 450000 w 645150"/>
+              <a:gd name="csY10" fmla="*/ 0 h 900000"/>
+              <a:gd name="csX0" fmla="*/ 450000 w 645150"/>
+              <a:gd name="csY0" fmla="*/ 0 h 900000"/>
+              <a:gd name="csX1" fmla="*/ 625161 w 645150"/>
+              <a:gd name="csY1" fmla="*/ 35364 h 900000"/>
+              <a:gd name="csX2" fmla="*/ 588701 w 645150"/>
+              <a:gd name="csY2" fmla="*/ 76853 h 900000"/>
+              <a:gd name="csX3" fmla="*/ 390300 w 645150"/>
+              <a:gd name="csY3" fmla="*/ 450000 h 900000"/>
+              <a:gd name="csX4" fmla="*/ 588701 w 645150"/>
+              <a:gd name="csY4" fmla="*/ 823147 h 900000"/>
+              <a:gd name="csX5" fmla="*/ 645150 w 645150"/>
+              <a:gd name="csY5" fmla="*/ 853787 h 900000"/>
+              <a:gd name="csX6" fmla="*/ 625161 w 645150"/>
+              <a:gd name="csY6" fmla="*/ 864637 h 900000"/>
+              <a:gd name="csX7" fmla="*/ 450000 w 645150"/>
+              <a:gd name="csY7" fmla="*/ 900000 h 900000"/>
+              <a:gd name="csX8" fmla="*/ 0 w 645150"/>
+              <a:gd name="csY8" fmla="*/ 450000 h 900000"/>
+              <a:gd name="csX9" fmla="*/ 450000 w 645150"/>
+              <a:gd name="csY9" fmla="*/ 0 h 900000"/>
+              <a:gd name="csX0" fmla="*/ 450000 w 625161"/>
+              <a:gd name="csY0" fmla="*/ 0 h 900000"/>
+              <a:gd name="csX1" fmla="*/ 625161 w 625161"/>
+              <a:gd name="csY1" fmla="*/ 35364 h 900000"/>
+              <a:gd name="csX2" fmla="*/ 588701 w 625161"/>
+              <a:gd name="csY2" fmla="*/ 76853 h 900000"/>
+              <a:gd name="csX3" fmla="*/ 390300 w 625161"/>
+              <a:gd name="csY3" fmla="*/ 450000 h 900000"/>
+              <a:gd name="csX4" fmla="*/ 588701 w 625161"/>
+              <a:gd name="csY4" fmla="*/ 823147 h 900000"/>
+              <a:gd name="csX5" fmla="*/ 625161 w 625161"/>
+              <a:gd name="csY5" fmla="*/ 864637 h 900000"/>
+              <a:gd name="csX6" fmla="*/ 450000 w 625161"/>
+              <a:gd name="csY6" fmla="*/ 900000 h 900000"/>
+              <a:gd name="csX7" fmla="*/ 0 w 625161"/>
+              <a:gd name="csY7" fmla="*/ 450000 h 900000"/>
+              <a:gd name="csX8" fmla="*/ 450000 w 625161"/>
+              <a:gd name="csY8" fmla="*/ 0 h 900000"/>
+              <a:gd name="csX0" fmla="*/ 450000 w 627137"/>
+              <a:gd name="csY0" fmla="*/ 0 h 900000"/>
+              <a:gd name="csX1" fmla="*/ 625161 w 627137"/>
+              <a:gd name="csY1" fmla="*/ 35364 h 900000"/>
+              <a:gd name="csX2" fmla="*/ 588701 w 627137"/>
+              <a:gd name="csY2" fmla="*/ 76853 h 900000"/>
+              <a:gd name="csX3" fmla="*/ 390300 w 627137"/>
+              <a:gd name="csY3" fmla="*/ 450000 h 900000"/>
+              <a:gd name="csX4" fmla="*/ 588701 w 627137"/>
+              <a:gd name="csY4" fmla="*/ 823147 h 900000"/>
+              <a:gd name="csX5" fmla="*/ 625161 w 627137"/>
+              <a:gd name="csY5" fmla="*/ 864637 h 900000"/>
+              <a:gd name="csX6" fmla="*/ 450000 w 627137"/>
+              <a:gd name="csY6" fmla="*/ 900000 h 900000"/>
+              <a:gd name="csX7" fmla="*/ 0 w 627137"/>
+              <a:gd name="csY7" fmla="*/ 450000 h 900000"/>
+              <a:gd name="csX8" fmla="*/ 450000 w 627137"/>
+              <a:gd name="csY8" fmla="*/ 0 h 900000"/>
+              <a:gd name="csX0" fmla="*/ 450000 w 627137"/>
+              <a:gd name="csY0" fmla="*/ 0 h 900000"/>
+              <a:gd name="csX1" fmla="*/ 625161 w 627137"/>
+              <a:gd name="csY1" fmla="*/ 35364 h 900000"/>
+              <a:gd name="csX2" fmla="*/ 588701 w 627137"/>
+              <a:gd name="csY2" fmla="*/ 76853 h 900000"/>
+              <a:gd name="csX3" fmla="*/ 390300 w 627137"/>
+              <a:gd name="csY3" fmla="*/ 450000 h 900000"/>
+              <a:gd name="csX4" fmla="*/ 588701 w 627137"/>
+              <a:gd name="csY4" fmla="*/ 823147 h 900000"/>
+              <a:gd name="csX5" fmla="*/ 625161 w 627137"/>
+              <a:gd name="csY5" fmla="*/ 864637 h 900000"/>
+              <a:gd name="csX6" fmla="*/ 450000 w 627137"/>
+              <a:gd name="csY6" fmla="*/ 900000 h 900000"/>
+              <a:gd name="csX7" fmla="*/ 0 w 627137"/>
+              <a:gd name="csY7" fmla="*/ 450000 h 900000"/>
+              <a:gd name="csX8" fmla="*/ 450000 w 627137"/>
+              <a:gd name="csY8" fmla="*/ 0 h 900000"/>
+            </a:gdLst>
+            <a:ahLst/>
+            <a:cxnLst>
+              <a:cxn ang="0">
+                <a:pos x="csX0" y="csY0"/>
+              </a:cxn>
+              <a:cxn ang="0">
+                <a:pos x="csX1" y="csY1"/>
+              </a:cxn>
+              <a:cxn ang="0">
+                <a:pos x="csX2" y="csY2"/>
+              </a:cxn>
+              <a:cxn ang="0">
+                <a:pos x="csX3" y="csY3"/>
+              </a:cxn>
+              <a:cxn ang="0">
+                <a:pos x="csX4" y="csY4"/>
+              </a:cxn>
+              <a:cxn ang="0">
+                <a:pos x="csX5" y="csY5"/>
+              </a:cxn>
+              <a:cxn ang="0">
+                <a:pos x="csX6" y="csY6"/>
+              </a:cxn>
+              <a:cxn ang="0">
+                <a:pos x="csX7" y="csY7"/>
+              </a:cxn>
+              <a:cxn ang="0">
+                <a:pos x="csX8" y="csY8"/>
+              </a:cxn>
+            </a:cxnLst>
+            <a:rect l="l" t="t" r="r" b="b"/>
+            <a:pathLst>
+              <a:path w="627137" h="900000">
+                <a:moveTo>
+                  <a:pt x="450000" y="0"/>
+                </a:moveTo>
+                <a:cubicBezTo>
+                  <a:pt x="512132" y="0"/>
+                  <a:pt x="571323" y="12592"/>
+                  <a:pt x="625161" y="35364"/>
+                </a:cubicBezTo>
+                <a:cubicBezTo>
+                  <a:pt x="635760" y="54886"/>
+                  <a:pt x="600854" y="63023"/>
+                  <a:pt x="588701" y="76853"/>
+                </a:cubicBezTo>
+                <a:cubicBezTo>
+                  <a:pt x="469000" y="157722"/>
+                  <a:pt x="390300" y="294670"/>
+                  <a:pt x="390300" y="450000"/>
+                </a:cubicBezTo>
+                <a:cubicBezTo>
+                  <a:pt x="390300" y="605330"/>
+                  <a:pt x="469000" y="742279"/>
+                  <a:pt x="588701" y="823147"/>
+                </a:cubicBezTo>
+                <a:cubicBezTo>
+                  <a:pt x="600854" y="836977"/>
+                  <a:pt x="630540" y="855442"/>
+                  <a:pt x="625161" y="864637"/>
+                </a:cubicBezTo>
+                <a:cubicBezTo>
+                  <a:pt x="571323" y="887408"/>
+                  <a:pt x="512132" y="900000"/>
+                  <a:pt x="450000" y="900000"/>
+                </a:cubicBezTo>
+                <a:cubicBezTo>
+                  <a:pt x="201472" y="900000"/>
+                  <a:pt x="0" y="698528"/>
+                  <a:pt x="0" y="450000"/>
+                </a:cubicBezTo>
+                <a:cubicBezTo>
+                  <a:pt x="0" y="201472"/>
+                  <a:pt x="201472" y="0"/>
+                  <a:pt x="450000" y="0"/>
+                </a:cubicBezTo>
+                <a:close/>
+              </a:path>
+            </a:pathLst>
+          </a:custGeom>
+          <a:solidFill>
+            <a:schemeClr val="tx1"/>
+          </a:solidFill>
+          <a:ln w="74613" cap="flat">
+            <a:noFill/>
+            <a:prstDash val="solid"/>
+            <a:miter/>
+          </a:ln>
+        </p:spPr>
+        <p:txBody>
+          <a:bodyPr wrap="square">
+            <a:noAutofit/>
+          </a:bodyPr>
+          <a:lstStyle/>
+          <a:p>
+            <a:endParaRPr lang="en-US"/>
+          </a:p>
+        </p:txBody>
+      </p:sp>
+      <p:sp>
+        <p:nvSpPr>
+          <p:cNvPr id="60" name="Oval 59">
+            <a:extLst>
+              <a:ext uri="{FF2B5EF4-FFF2-40B4-BE49-F238E27FC236}">
+                <a16:creationId xmlns:a16="http://schemas.microsoft.com/office/drawing/2014/main" id="{15E3DDD9-29D5-C838-07EA-30CB87E8C12F}"/>
+              </a:ext>
+            </a:extLst>
+          </p:cNvPr>
+          <p:cNvSpPr/>
+          <p:nvPr/>
+        </p:nvSpPr>
+        <p:spPr>
+          <a:xfrm>
+            <a:off x="3281820" y="968525"/>
+            <a:ext cx="151200" cy="151200"/>
+          </a:xfrm>
+          <a:prstGeom prst="ellipse">
+            <a:avLst/>
+          </a:prstGeom>
+          <a:solidFill>
+            <a:schemeClr val="tx1"/>
+          </a:solidFill>
+          <a:ln>
+            <a:noFill/>
+          </a:ln>
+        </p:spPr>
+        <p:style>
+          <a:lnRef idx="2">
+            <a:schemeClr val="accent1">
+              <a:shade val="15000"/>
+            </a:schemeClr>
+          </a:lnRef>
+          <a:fillRef idx="1">
+            <a:schemeClr val="accent1"/>
+          </a:fillRef>
+          <a:effectRef idx="0">
+            <a:schemeClr val="accent1"/>
+          </a:effectRef>
+          <a:fontRef idx="minor">
+            <a:schemeClr val="lt1"/>
+          </a:fontRef>
+        </p:style>
+        <p:txBody>
+          <a:bodyPr rtlCol="0" anchor="ctr"/>
+          <a:lstStyle/>
+          <a:p>
+            <a:pPr algn="ctr"/>
+            <a:endParaRPr lang="en-US"/>
+          </a:p>
+        </p:txBody>
+      </p:sp>
+      <p:sp>
+        <p:nvSpPr>
+          <p:cNvPr id="61" name="Oval 60">
+            <a:extLst>
+              <a:ext uri="{FF2B5EF4-FFF2-40B4-BE49-F238E27FC236}">
+                <a16:creationId xmlns:a16="http://schemas.microsoft.com/office/drawing/2014/main" id="{72DE3F93-8974-B215-5337-8E0A04E3786A}"/>
+              </a:ext>
+            </a:extLst>
+          </p:cNvPr>
+          <p:cNvSpPr/>
+          <p:nvPr/>
+        </p:nvSpPr>
+        <p:spPr>
+          <a:xfrm>
+            <a:off x="4432917" y="491228"/>
+            <a:ext cx="151200" cy="151200"/>
+          </a:xfrm>
+          <a:prstGeom prst="ellipse">
+            <a:avLst/>
+          </a:prstGeom>
+          <a:solidFill>
+            <a:schemeClr val="tx1"/>
+          </a:solidFill>
+          <a:ln>
+            <a:noFill/>
+          </a:ln>
+        </p:spPr>
+        <p:style>
+          <a:lnRef idx="2">
+            <a:schemeClr val="accent1">
+              <a:shade val="15000"/>
+            </a:schemeClr>
+          </a:lnRef>
+          <a:fillRef idx="1">
+            <a:schemeClr val="accent1"/>
+          </a:fillRef>
+          <a:effectRef idx="0">
+            <a:schemeClr val="accent1"/>
+          </a:effectRef>
+          <a:fontRef idx="minor">
+            <a:schemeClr val="lt1"/>
+          </a:fontRef>
+        </p:style>
+        <p:txBody>
+          <a:bodyPr rtlCol="0" anchor="ctr"/>
+          <a:lstStyle/>
+          <a:p>
+            <a:pPr algn="ctr"/>
+            <a:endParaRPr lang="en-US"/>
+          </a:p>
+        </p:txBody>
+      </p:sp>
+      <p:sp>
+        <p:nvSpPr>
+          <p:cNvPr id="62" name="Oval 61">
+            <a:extLst>
+              <a:ext uri="{FF2B5EF4-FFF2-40B4-BE49-F238E27FC236}">
+                <a16:creationId xmlns:a16="http://schemas.microsoft.com/office/drawing/2014/main" id="{79A09F4D-B561-04A3-CA44-B06913069C01}"/>
+              </a:ext>
+            </a:extLst>
+          </p:cNvPr>
+          <p:cNvSpPr/>
+          <p:nvPr/>
+        </p:nvSpPr>
+        <p:spPr>
+          <a:xfrm>
+            <a:off x="3955620" y="293525"/>
+            <a:ext cx="151200" cy="151200"/>
+          </a:xfrm>
+          <a:prstGeom prst="ellipse">
+            <a:avLst/>
+          </a:prstGeom>
+          <a:solidFill>
+            <a:schemeClr val="tx1"/>
+          </a:solidFill>
+          <a:ln>
+            <a:noFill/>
+          </a:ln>
+        </p:spPr>
+        <p:style>
+          <a:lnRef idx="2">
+            <a:schemeClr val="accent1">
+              <a:shade val="15000"/>
+            </a:schemeClr>
+          </a:lnRef>
+          <a:fillRef idx="1">
+            <a:schemeClr val="accent1"/>
+          </a:fillRef>
+          <a:effectRef idx="0">
+            <a:schemeClr val="accent1"/>
+          </a:effectRef>
+          <a:fontRef idx="minor">
+            <a:schemeClr val="lt1"/>
+          </a:fontRef>
+        </p:style>
+        <p:txBody>
+          <a:bodyPr rtlCol="0" anchor="ctr"/>
+          <a:lstStyle/>
+          <a:p>
+            <a:pPr algn="ctr"/>
+            <a:endParaRPr lang="en-US"/>
+          </a:p>
+        </p:txBody>
+      </p:sp>
+      <p:sp>
+        <p:nvSpPr>
+          <p:cNvPr id="63" name="Oval 62">
+            <a:extLst>
+              <a:ext uri="{FF2B5EF4-FFF2-40B4-BE49-F238E27FC236}">
+                <a16:creationId xmlns:a16="http://schemas.microsoft.com/office/drawing/2014/main" id="{8FED497A-CBDA-DC55-F7EB-3213FFB3BFE3}"/>
+              </a:ext>
+            </a:extLst>
+          </p:cNvPr>
+          <p:cNvSpPr/>
+          <p:nvPr/>
+        </p:nvSpPr>
+        <p:spPr>
+          <a:xfrm>
+            <a:off x="3479522" y="491228"/>
+            <a:ext cx="151200" cy="151200"/>
+          </a:xfrm>
+          <a:prstGeom prst="ellipse">
+            <a:avLst/>
+          </a:prstGeom>
+          <a:solidFill>
+            <a:schemeClr val="tx1"/>
+          </a:solidFill>
+          <a:ln>
+            <a:noFill/>
+          </a:ln>
+        </p:spPr>
+        <p:style>
+          <a:lnRef idx="2">
+            <a:schemeClr val="accent1">
+              <a:shade val="15000"/>
+            </a:schemeClr>
+          </a:lnRef>
+          <a:fillRef idx="1">
+            <a:schemeClr val="accent1"/>
+          </a:fillRef>
+          <a:effectRef idx="0">
+            <a:schemeClr val="accent1"/>
+          </a:effectRef>
+          <a:fontRef idx="minor">
+            <a:schemeClr val="lt1"/>
+          </a:fontRef>
+        </p:style>
+        <p:txBody>
+          <a:bodyPr rtlCol="0" anchor="ctr"/>
+          <a:lstStyle/>
+          <a:p>
+            <a:pPr algn="ctr"/>
+            <a:endParaRPr lang="en-US"/>
+          </a:p>
+        </p:txBody>
+      </p:sp>
+      <p:sp>
+        <p:nvSpPr>
+          <p:cNvPr id="64" name="Oval 63">
+            <a:extLst>
+              <a:ext uri="{FF2B5EF4-FFF2-40B4-BE49-F238E27FC236}">
+                <a16:creationId xmlns:a16="http://schemas.microsoft.com/office/drawing/2014/main" id="{F67BDBD3-3376-BE31-A6D5-09E7F2403D49}"/>
+              </a:ext>
+            </a:extLst>
+          </p:cNvPr>
+          <p:cNvSpPr/>
+          <p:nvPr/>
+        </p:nvSpPr>
+        <p:spPr>
+          <a:xfrm>
+            <a:off x="4630620" y="968525"/>
+            <a:ext cx="151200" cy="151200"/>
+          </a:xfrm>
+          <a:prstGeom prst="ellipse">
+            <a:avLst/>
+          </a:prstGeom>
+          <a:solidFill>
+            <a:schemeClr val="tx1"/>
+          </a:solidFill>
+          <a:ln>
+            <a:noFill/>
+          </a:ln>
+        </p:spPr>
+        <p:style>
+          <a:lnRef idx="2">
+            <a:schemeClr val="accent1">
+              <a:shade val="15000"/>
+            </a:schemeClr>
+          </a:lnRef>
+          <a:fillRef idx="1">
+            <a:schemeClr val="accent1"/>
+          </a:fillRef>
+          <a:effectRef idx="0">
+            <a:schemeClr val="accent1"/>
+          </a:effectRef>
+          <a:fontRef idx="minor">
+            <a:schemeClr val="lt1"/>
+          </a:fontRef>
+        </p:style>
+        <p:txBody>
+          <a:bodyPr rtlCol="0" anchor="ctr"/>
+          <a:lstStyle/>
+          <a:p>
+            <a:pPr algn="ctr"/>
+            <a:endParaRPr lang="en-US"/>
+          </a:p>
+        </p:txBody>
+      </p:sp>
+      <p:sp>
+        <p:nvSpPr>
+          <p:cNvPr id="65" name="Oval 64">
+            <a:extLst>
+              <a:ext uri="{FF2B5EF4-FFF2-40B4-BE49-F238E27FC236}">
+                <a16:creationId xmlns:a16="http://schemas.microsoft.com/office/drawing/2014/main" id="{94A10547-6900-4A53-6C6A-752559744030}"/>
+              </a:ext>
+            </a:extLst>
+          </p:cNvPr>
+          <p:cNvSpPr/>
+          <p:nvPr/>
+        </p:nvSpPr>
+        <p:spPr>
+          <a:xfrm>
+            <a:off x="3479522" y="1444622"/>
+            <a:ext cx="151200" cy="151200"/>
+          </a:xfrm>
+          <a:prstGeom prst="ellipse">
+            <a:avLst/>
+          </a:prstGeom>
+          <a:solidFill>
+            <a:schemeClr val="tx1"/>
+          </a:solidFill>
+          <a:ln>
+            <a:noFill/>
+          </a:ln>
+        </p:spPr>
+        <p:style>
+          <a:lnRef idx="2">
+            <a:schemeClr val="accent1">
+              <a:shade val="15000"/>
+            </a:schemeClr>
+          </a:lnRef>
+          <a:fillRef idx="1">
+            <a:schemeClr val="accent1"/>
+          </a:fillRef>
+          <a:effectRef idx="0">
+            <a:schemeClr val="accent1"/>
+          </a:effectRef>
+          <a:fontRef idx="minor">
+            <a:schemeClr val="lt1"/>
+          </a:fontRef>
+        </p:style>
+        <p:txBody>
+          <a:bodyPr rtlCol="0" anchor="ctr"/>
+          <a:lstStyle/>
+          <a:p>
+            <a:pPr algn="ctr"/>
+            <a:endParaRPr lang="en-US"/>
+          </a:p>
+        </p:txBody>
+      </p:sp>
+      <p:sp>
+        <p:nvSpPr>
+          <p:cNvPr id="66" name="Oval 65">
+            <a:extLst>
+              <a:ext uri="{FF2B5EF4-FFF2-40B4-BE49-F238E27FC236}">
+                <a16:creationId xmlns:a16="http://schemas.microsoft.com/office/drawing/2014/main" id="{3F5D8FF3-A71D-130C-903D-D9C864644AF5}"/>
+              </a:ext>
+            </a:extLst>
+          </p:cNvPr>
+          <p:cNvSpPr/>
+          <p:nvPr/>
+        </p:nvSpPr>
+        <p:spPr>
+          <a:xfrm>
+            <a:off x="3956820" y="1642325"/>
+            <a:ext cx="151200" cy="151200"/>
+          </a:xfrm>
+          <a:prstGeom prst="ellipse">
+            <a:avLst/>
+          </a:prstGeom>
+          <a:solidFill>
+            <a:schemeClr val="tx1"/>
+          </a:solidFill>
+          <a:ln>
+            <a:noFill/>
+          </a:ln>
+        </p:spPr>
+        <p:style>
+          <a:lnRef idx="2">
+            <a:schemeClr val="accent1">
+              <a:shade val="15000"/>
+            </a:schemeClr>
+          </a:lnRef>
+          <a:fillRef idx="1">
+            <a:schemeClr val="accent1"/>
+          </a:fillRef>
+          <a:effectRef idx="0">
+            <a:schemeClr val="accent1"/>
+          </a:effectRef>
+          <a:fontRef idx="minor">
+            <a:schemeClr val="lt1"/>
+          </a:fontRef>
+        </p:style>
+        <p:txBody>
+          <a:bodyPr rtlCol="0" anchor="ctr"/>
+          <a:lstStyle/>
+          <a:p>
+            <a:pPr algn="ctr"/>
+            <a:endParaRPr lang="en-US"/>
+          </a:p>
+        </p:txBody>
+      </p:sp>
+      <p:sp>
+        <p:nvSpPr>
+          <p:cNvPr id="67" name="Oval 66">
+            <a:extLst>
+              <a:ext uri="{FF2B5EF4-FFF2-40B4-BE49-F238E27FC236}">
+                <a16:creationId xmlns:a16="http://schemas.microsoft.com/office/drawing/2014/main" id="{31CBEC7B-19BD-22A3-E56C-4A93D1516BE2}"/>
+              </a:ext>
+            </a:extLst>
+          </p:cNvPr>
+          <p:cNvSpPr/>
+          <p:nvPr/>
+        </p:nvSpPr>
+        <p:spPr>
+          <a:xfrm>
+            <a:off x="4432917" y="1444622"/>
+            <a:ext cx="151200" cy="151200"/>
+          </a:xfrm>
+          <a:prstGeom prst="ellipse">
+            <a:avLst/>
+          </a:prstGeom>
+          <a:solidFill>
+            <a:schemeClr val="tx1"/>
+          </a:solidFill>
+          <a:ln>
+            <a:noFill/>
+          </a:ln>
+        </p:spPr>
+        <p:style>
+          <a:lnRef idx="2">
+            <a:schemeClr val="accent1">
+              <a:shade val="15000"/>
+            </a:schemeClr>
+          </a:lnRef>
+          <a:fillRef idx="1">
+            <a:schemeClr val="accent1"/>
+          </a:fillRef>
+          <a:effectRef idx="0">
+            <a:schemeClr val="accent1"/>
+          </a:effectRef>
+          <a:fontRef idx="minor">
+            <a:schemeClr val="lt1"/>
+          </a:fontRef>
+        </p:style>
+        <p:txBody>
+          <a:bodyPr rtlCol="0" anchor="ctr"/>
+          <a:lstStyle/>
+          <a:p>
+            <a:pPr algn="ctr"/>
+            <a:endParaRPr lang="en-US"/>
+          </a:p>
+        </p:txBody>
+      </p:sp>
+    </p:spTree>
+    <p:extLst>
+      <p:ext uri="{BB962C8B-B14F-4D97-AF65-F5344CB8AC3E}">
+        <p14:creationId xmlns:p14="http://schemas.microsoft.com/office/powerpoint/2010/main" val="1116993007"/>
+      </p:ext>
+    </p:extLst>
+  </p:cSld>
+  <p:clrMapOvr>
+    <a:masterClrMapping/>
+  </p:clrMapOvr>
+</p:sld>
+</file>
+
 <file path=ppt/theme/theme1.xml><?xml version="1.0" encoding="utf-8"?>
 <a:theme xmlns:a="http://schemas.openxmlformats.org/drawingml/2006/main" name="Office Theme">
   <a:themeElements>

</xml_diff>